<commit_message>
refactor: align pitch deck and PITCH_DECK with new CraftCut narrative
- Pop culture entry → labels → youth podcasts
- Editorial duo, satellite pages, voice cloning EU
- Cloud-ready positioning (no M3/Gutenberg/Apple Music refs)
- Regenerated 12-slide CraftCut_Pitch_Deck.pptx
</commit_message>
<xml_diff>
--- a/CraftCut_Pitch_Deck.pptx
+++ b/CraftCut_Pitch_Deck.pptx
@@ -1951,7 +1951,7 @@
                 <a:ea typeface="Calibri" pitchFamily="34" charset="-122"/>
                 <a:cs typeface="Calibri" pitchFamily="34" charset="-120"/>
               </a:rPr>
-              <a:t>César+ Start-up — Presse verticale souveraine</a:t>
+              <a:t>Automatisation vidéo IA pour marques exigeantes</a:t>
             </a:r>
             <a:endParaRPr lang="en-US" sz="1600" dirty="0"/>
           </a:p>
@@ -2097,7 +2097,7 @@
                 <a:ea typeface="Georgia" pitchFamily="34" charset="-122"/>
                 <a:cs typeface="Georgia" pitchFamily="34" charset="-120"/>
               </a:rPr>
-              <a:t>Station F &amp; HEC</a:t>
+              <a:t>Volume opérationnel</a:t>
             </a:r>
             <a:endParaRPr lang="en-US" sz="3400" dirty="0"/>
           </a:p>
@@ -2136,7 +2136,7 @@
                 <a:ea typeface="Calibri" pitchFamily="34" charset="-122"/>
                 <a:cs typeface="Calibri" pitchFamily="34" charset="-120"/>
               </a:rPr>
-              <a:t>Candidature Fall/Winter 2026</a:t>
+              <a:t>Justification crédits cloud entreprise</a:t>
             </a:r>
             <a:endParaRPr lang="en-US" sz="1300" dirty="0"/>
           </a:p>
@@ -2144,20 +2144,137 @@
       </p:sp>
       <p:sp>
         <p:nvSpPr>
-          <p:cNvPr id="4" name="Shape 2"/>
+          <p:cNvPr id="4" name="Text 2"/>
           <p:cNvSpPr/>
           <p:nvPr/>
         </p:nvSpPr>
         <p:spPr>
           <a:xfrm>
             <a:off x="640080" y="1828800"/>
-            <a:ext cx="3840480" cy="2286000"/>
+            <a:ext cx="5029200" cy="1097280"/>
+          </a:xfrm>
+          <a:prstGeom prst="rect">
+            <a:avLst/>
+          </a:prstGeom>
+          <a:noFill/>
+          <a:ln/>
+        </p:spPr>
+        <p:txBody>
+          <a:bodyPr wrap="square" lIns="0" tIns="0" rIns="0" bIns="0" rtlCol="0" anchor="ctr"/>
+          <a:lstStyle/>
+          <a:p>
+            <a:pPr indent="0" marL="0">
+              <a:buNone/>
+            </a:pPr>
+            <a:r>
+              <a:rPr lang="en-US" sz="7200" b="1" dirty="0">
+                <a:solidFill>
+                  <a:srgbClr val="B85042"/>
+                </a:solidFill>
+                <a:latin typeface="Georgia" pitchFamily="34" charset="0"/>
+                <a:ea typeface="Georgia" pitchFamily="34" charset="-122"/>
+                <a:cs typeface="Georgia" pitchFamily="34" charset="-120"/>
+              </a:rPr>
+              <a:t>64,3</a:t>
+            </a:r>
+            <a:endParaRPr lang="en-US" sz="7200" dirty="0"/>
+          </a:p>
+        </p:txBody>
+      </p:sp>
+      <p:sp>
+        <p:nvSpPr>
+          <p:cNvPr id="5" name="Text 3"/>
+          <p:cNvSpPr/>
+          <p:nvPr/>
+        </p:nvSpPr>
+        <p:spPr>
+          <a:xfrm>
+            <a:off x="640080" y="2834640"/>
+            <a:ext cx="5029200" cy="457200"/>
+          </a:xfrm>
+          <a:prstGeom prst="rect">
+            <a:avLst/>
+          </a:prstGeom>
+          <a:noFill/>
+          <a:ln/>
+        </p:spPr>
+        <p:txBody>
+          <a:bodyPr wrap="square" lIns="0" tIns="0" rIns="0" bIns="0" rtlCol="0" anchor="ctr"/>
+          <a:lstStyle/>
+          <a:p>
+            <a:pPr indent="0" marL="0">
+              <a:buNone/>
+            </a:pPr>
+            <a:r>
+              <a:rPr lang="en-US" sz="1800" dirty="0">
+                <a:solidFill>
+                  <a:srgbClr val="1A1A19"/>
+                </a:solidFill>
+                <a:latin typeface="Calibri" pitchFamily="34" charset="0"/>
+                <a:ea typeface="Calibri" pitchFamily="34" charset="-122"/>
+                <a:cs typeface="Calibri" pitchFamily="34" charset="-120"/>
+              </a:rPr>
+              <a:t>Millions de tokens / mois</a:t>
+            </a:r>
+            <a:endParaRPr lang="en-US" sz="1800" dirty="0"/>
+          </a:p>
+        </p:txBody>
+      </p:sp>
+      <p:sp>
+        <p:nvSpPr>
+          <p:cNvPr id="6" name="Text 4"/>
+          <p:cNvSpPr/>
+          <p:nvPr/>
+        </p:nvSpPr>
+        <p:spPr>
+          <a:xfrm>
+            <a:off x="640080" y="3383280"/>
+            <a:ext cx="7772400" cy="365760"/>
+          </a:xfrm>
+          <a:prstGeom prst="rect">
+            <a:avLst/>
+          </a:prstGeom>
+          <a:noFill/>
+          <a:ln/>
+        </p:spPr>
+        <p:txBody>
+          <a:bodyPr wrap="square" lIns="0" tIns="0" rIns="0" bIns="0" rtlCol="0" anchor="ctr"/>
+          <a:lstStyle/>
+          <a:p>
+            <a:pPr indent="0" marL="0">
+              <a:buNone/>
+            </a:pPr>
+            <a:r>
+              <a:rPr lang="en-US" sz="1000" dirty="0">
+                <a:solidFill>
+                  <a:srgbClr val="6B6B68"/>
+                </a:solidFill>
+                <a:latin typeface="Consolas" pitchFamily="34" charset="0"/>
+                <a:ea typeface="Consolas" pitchFamily="34" charset="-122"/>
+                <a:cs typeface="Consolas" pitchFamily="34" charset="-120"/>
+              </a:rPr>
+              <a:t>50 cycles × 31 000 tokens × 30 jours  |  350 sorties localisées/jour</a:t>
+            </a:r>
+            <a:endParaRPr lang="en-US" sz="1000" dirty="0"/>
+          </a:p>
+        </p:txBody>
+      </p:sp>
+      <p:sp>
+        <p:nvSpPr>
+          <p:cNvPr id="7" name="Shape 5"/>
+          <p:cNvSpPr/>
+          <p:nvPr/>
+        </p:nvSpPr>
+        <p:spPr>
+          <a:xfrm>
+            <a:off x="6217920" y="1828800"/>
+            <a:ext cx="2468880" cy="2286000"/>
           </a:xfrm>
           <a:prstGeom prst="rect">
             <a:avLst/>
           </a:prstGeom>
           <a:solidFill>
-            <a:srgbClr val="FFFFFF"/>
+            <a:srgbClr val="E7E8D1"/>
           </a:solidFill>
           <a:ln w="12700">
             <a:solidFill>
@@ -2169,39 +2286,14 @@
       </p:sp>
       <p:sp>
         <p:nvSpPr>
-          <p:cNvPr id="5" name="Shape 3"/>
-          <p:cNvSpPr/>
-          <p:nvPr/>
-        </p:nvSpPr>
-        <p:spPr>
-          <a:xfrm>
-            <a:off x="640080" y="1828800"/>
-            <a:ext cx="64008" cy="2286000"/>
-          </a:xfrm>
-          <a:prstGeom prst="rect">
-            <a:avLst/>
-          </a:prstGeom>
-          <a:solidFill>
-            <a:srgbClr val="B85042"/>
-          </a:solidFill>
-          <a:ln w="12700">
-            <a:solidFill>
-              <a:srgbClr val="B85042"/>
-            </a:solidFill>
-            <a:prstDash val="solid"/>
-          </a:ln>
-        </p:spPr>
-      </p:sp>
-      <p:sp>
-        <p:nvSpPr>
-          <p:cNvPr id="6" name="Text 4"/>
-          <p:cNvSpPr/>
-          <p:nvPr/>
-        </p:nvSpPr>
-        <p:spPr>
-          <a:xfrm>
-            <a:off x="841248" y="1993392"/>
-            <a:ext cx="3520440" cy="320040"/>
+          <p:cNvPr id="8" name="Text 6"/>
+          <p:cNvSpPr/>
+          <p:nvPr/>
+        </p:nvSpPr>
+        <p:spPr>
+          <a:xfrm>
+            <a:off x="6309360" y="2103120"/>
+            <a:ext cx="2286000" cy="1828800"/>
           </a:xfrm>
           <a:prstGeom prst="rect">
             <a:avLst/>
@@ -2213,194 +2305,52 @@
           <a:bodyPr wrap="square" lIns="0" tIns="0" rIns="0" bIns="0" rtlCol="0" anchor="ctr"/>
           <a:lstStyle/>
           <a:p>
-            <a:pPr indent="0" marL="0">
-              <a:buNone/>
-            </a:pPr>
-            <a:r>
-              <a:rPr lang="en-US" sz="1400" b="1" dirty="0">
+            <a:pPr algn="ctr" indent="0" marL="0">
+              <a:buNone/>
+            </a:pPr>
+            <a:r>
+              <a:rPr lang="en-US" sz="1200" b="1" dirty="0">
                 <a:solidFill>
                   <a:srgbClr val="1A1A19"/>
                 </a:solidFill>
-                <a:latin typeface="Georgia" pitchFamily="34" charset="0"/>
-                <a:ea typeface="Georgia" pitchFamily="34" charset="-122"/>
-                <a:cs typeface="Georgia" pitchFamily="34" charset="-120"/>
-              </a:rPr>
-              <a:t>Incubateur HEC Paris</a:t>
-            </a:r>
-            <a:endParaRPr lang="en-US" sz="1400" dirty="0"/>
-          </a:p>
-        </p:txBody>
-      </p:sp>
-      <p:sp>
-        <p:nvSpPr>
-          <p:cNvPr id="7" name="Text 5"/>
-          <p:cNvSpPr/>
-          <p:nvPr/>
-        </p:nvSpPr>
-        <p:spPr>
-          <a:xfrm>
-            <a:off x="841248" y="2331720"/>
-            <a:ext cx="3520440" cy="1645920"/>
-          </a:xfrm>
-          <a:prstGeom prst="rect">
-            <a:avLst/>
-          </a:prstGeom>
-          <a:noFill/>
-          <a:ln/>
-        </p:spPr>
-        <p:txBody>
-          <a:bodyPr wrap="square" lIns="0" tIns="0" rIns="0" bIns="0" rtlCol="0" anchor="t"/>
-          <a:lstStyle/>
-          <a:p>
-            <a:pPr indent="0" marL="0">
-              <a:buNone/>
-            </a:pPr>
-            <a:r>
-              <a:rPr lang="en-US" sz="1100" dirty="0">
-                <a:solidFill>
-                  <a:srgbClr val="6B6B68"/>
-                </a:solidFill>
-                <a:latin typeface="Calibri" pitchFamily="34" charset="0"/>
-                <a:ea typeface="Calibri" pitchFamily="34" charset="-122"/>
-                <a:cs typeface="Calibri" pitchFamily="34" charset="-120"/>
-              </a:rPr>
-              <a:t>Patrimoine, design, luxe — alignement parfait avec Ouvriers de France.</a:t>
-            </a:r>
-            <a:endParaRPr lang="en-US" sz="1100" dirty="0"/>
-          </a:p>
-        </p:txBody>
-      </p:sp>
-      <p:sp>
-        <p:nvSpPr>
-          <p:cNvPr id="8" name="Shape 6"/>
-          <p:cNvSpPr/>
-          <p:nvPr/>
-        </p:nvSpPr>
-        <p:spPr>
-          <a:xfrm>
-            <a:off x="4754880" y="1828800"/>
-            <a:ext cx="3931920" cy="2286000"/>
-          </a:xfrm>
-          <a:prstGeom prst="rect">
-            <a:avLst/>
-          </a:prstGeom>
-          <a:solidFill>
-            <a:srgbClr val="FFFFFF"/>
-          </a:solidFill>
-          <a:ln w="12700">
-            <a:solidFill>
-              <a:srgbClr val="D8D8D4"/>
-            </a:solidFill>
-            <a:prstDash val="solid"/>
-          </a:ln>
-        </p:spPr>
-      </p:sp>
-      <p:sp>
-        <p:nvSpPr>
-          <p:cNvPr id="9" name="Shape 7"/>
-          <p:cNvSpPr/>
-          <p:nvPr/>
-        </p:nvSpPr>
-        <p:spPr>
-          <a:xfrm>
-            <a:off x="4754880" y="1828800"/>
-            <a:ext cx="64008" cy="2286000"/>
-          </a:xfrm>
-          <a:prstGeom prst="rect">
-            <a:avLst/>
-          </a:prstGeom>
-          <a:solidFill>
-            <a:srgbClr val="B85042"/>
-          </a:solidFill>
-          <a:ln w="12700">
-            <a:solidFill>
-              <a:srgbClr val="B85042"/>
-            </a:solidFill>
-            <a:prstDash val="solid"/>
-          </a:ln>
-        </p:spPr>
-      </p:sp>
-      <p:sp>
-        <p:nvSpPr>
-          <p:cNvPr id="10" name="Text 8"/>
-          <p:cNvSpPr/>
-          <p:nvPr/>
-        </p:nvSpPr>
-        <p:spPr>
-          <a:xfrm>
-            <a:off x="4956048" y="1993392"/>
-            <a:ext cx="3611880" cy="320040"/>
-          </a:xfrm>
-          <a:prstGeom prst="rect">
-            <a:avLst/>
-          </a:prstGeom>
-          <a:noFill/>
-          <a:ln/>
-        </p:spPr>
-        <p:txBody>
-          <a:bodyPr wrap="square" lIns="0" tIns="0" rIns="0" bIns="0" rtlCol="0" anchor="ctr"/>
-          <a:lstStyle/>
-          <a:p>
-            <a:pPr indent="0" marL="0">
-              <a:buNone/>
-            </a:pPr>
-            <a:r>
-              <a:rPr lang="en-US" sz="1400" b="1" dirty="0">
+              </a:rPr>
+              <a:t>Cible crédits</a:t>
+            </a:r>
+            <a:endParaRPr lang="en-US" sz="1200" dirty="0"/>
+          </a:p>
+          <a:p>
+            <a:pPr algn="ctr" indent="0" marL="0">
+              <a:buNone/>
+            </a:pPr>
+            <a:r>
+              <a:rPr lang="en-US" sz="1200" b="1" dirty="0">
                 <a:solidFill>
                   <a:srgbClr val="1A1A19"/>
                 </a:solidFill>
-                <a:latin typeface="Georgia" pitchFamily="34" charset="0"/>
-                <a:ea typeface="Georgia" pitchFamily="34" charset="-122"/>
-                <a:cs typeface="Georgia" pitchFamily="34" charset="-120"/>
-              </a:rPr>
-              <a:t>Founders Program</a:t>
-            </a:r>
-            <a:endParaRPr lang="en-US" sz="1400" dirty="0"/>
-          </a:p>
-        </p:txBody>
-      </p:sp>
-      <p:sp>
-        <p:nvSpPr>
-          <p:cNvPr id="11" name="Text 9"/>
-          <p:cNvSpPr/>
-          <p:nvPr/>
-        </p:nvSpPr>
-        <p:spPr>
-          <a:xfrm>
-            <a:off x="4956048" y="2331720"/>
-            <a:ext cx="3611880" cy="1645920"/>
-          </a:xfrm>
-          <a:prstGeom prst="rect">
-            <a:avLst/>
-          </a:prstGeom>
-          <a:noFill/>
-          <a:ln/>
-        </p:spPr>
-        <p:txBody>
-          <a:bodyPr wrap="square" lIns="0" tIns="0" rIns="0" bIns="0" rtlCol="0" anchor="t"/>
-          <a:lstStyle/>
-          <a:p>
-            <a:pPr indent="0" marL="0">
-              <a:buNone/>
-            </a:pPr>
-            <a:r>
-              <a:rPr lang="en-US" sz="1100" dirty="0">
-                <a:solidFill>
-                  <a:srgbClr val="6B6B68"/>
-                </a:solidFill>
-                <a:latin typeface="Calibri" pitchFamily="34" charset="0"/>
-                <a:ea typeface="Calibri" pitchFamily="34" charset="-122"/>
-                <a:cs typeface="Calibri" pitchFamily="34" charset="-120"/>
-              </a:rPr>
-              <a:t>MVP live, scalabilité 350 vidéos/jour, fondateur-architecte système.</a:t>
-            </a:r>
-            <a:endParaRPr lang="en-US" sz="1100" dirty="0"/>
-          </a:p>
-        </p:txBody>
-      </p:sp>
-      <p:sp>
-        <p:nvSpPr>
-          <p:cNvPr id="12" name="Text 10"/>
+              </a:rPr>
+              <a:t>$25k – $100k</a:t>
+            </a:r>
+            <a:endParaRPr lang="en-US" sz="1200" dirty="0"/>
+          </a:p>
+          <a:p>
+            <a:pPr algn="ctr" indent="0" marL="0">
+              <a:buNone/>
+            </a:pPr>
+            <a:r>
+              <a:rPr lang="en-US" sz="1200" b="1" dirty="0">
+                <a:solidFill>
+                  <a:srgbClr val="1A1A19"/>
+                </a:solidFill>
+              </a:rPr>
+              <a:t>via HAL Station F</a:t>
+            </a:r>
+            <a:endParaRPr lang="en-US" sz="1200" dirty="0"/>
+          </a:p>
+        </p:txBody>
+      </p:sp>
+      <p:sp>
+        <p:nvSpPr>
+          <p:cNvPr id="9" name="Text 7"/>
           <p:cNvSpPr/>
           <p:nvPr/>
         </p:nvSpPr>
@@ -2538,7 +2488,7 @@
                 <a:ea typeface="Calibri" pitchFamily="34" charset="-122"/>
                 <a:cs typeface="Calibri" pitchFamily="34" charset="-120"/>
               </a:rPr>
-              <a:t>Opportunité 2026</a:t>
+              <a:t>Go-to-market 2026</a:t>
             </a:r>
             <a:endParaRPr lang="en-US" sz="1300" dirty="0"/>
           </a:p>
@@ -2627,7 +2577,7 @@
                 <a:ea typeface="Georgia" pitchFamily="34" charset="-122"/>
                 <a:cs typeface="Georgia" pitchFamily="34" charset="-120"/>
               </a:rPr>
-              <a:t>Maisons de luxe</a:t>
+              <a:t>Labels &amp; artistes</a:t>
             </a:r>
             <a:endParaRPr lang="en-US" sz="1400" dirty="0"/>
           </a:p>
@@ -2666,7 +2616,7 @@
                 <a:ea typeface="Calibri" pitchFamily="34" charset="-122"/>
                 <a:cs typeface="Calibri" pitchFamily="34" charset="-120"/>
               </a:rPr>
-              <a:t>Scaler la présence verticale sans diluer l'identité visuelle.</a:t>
+              <a:t>Pop culture et couvertures d'album comme vecteur d'entrée.</a:t>
             </a:r>
             <a:endParaRPr lang="en-US" sz="1100" dirty="0"/>
           </a:p>
@@ -2755,7 +2705,7 @@
                 <a:ea typeface="Georgia" pitchFamily="34" charset="-122"/>
                 <a:cs typeface="Georgia" pitchFamily="34" charset="-120"/>
               </a:rPr>
-              <a:t>Institutions culturelles</a:t>
+              <a:t>Marques exigeantes</a:t>
             </a:r>
             <a:endParaRPr lang="en-US" sz="1400" dirty="0"/>
           </a:p>
@@ -2794,7 +2744,7 @@
                 <a:ea typeface="Calibri" pitchFamily="34" charset="-122"/>
                 <a:cs typeface="Calibri" pitchFamily="34" charset="-120"/>
               </a:rPr>
-              <a:t>Exporter l'artisanat régional en 7 langues.</a:t>
+              <a:t>Automatisation IA respectant un cahier des charges motion design élevé.</a:t>
             </a:r>
             <a:endParaRPr lang="en-US" sz="1100" dirty="0"/>
           </a:p>
@@ -2883,7 +2833,7 @@
                 <a:ea typeface="Georgia" pitchFamily="34" charset="-122"/>
                 <a:cs typeface="Georgia" pitchFamily="34" charset="-120"/>
               </a:rPr>
-              <a:t>Labels &amp; créateurs</a:t>
+              <a:t>Institutions &amp; EU</a:t>
             </a:r>
             <a:endParaRPr lang="en-US" sz="1400" dirty="0"/>
           </a:p>
@@ -2922,7 +2872,7 @@
                 <a:ea typeface="Calibri" pitchFamily="34" charset="-122"/>
                 <a:cs typeface="Calibri" pitchFamily="34" charset="-120"/>
               </a:rPr>
-              <a:t>Pochettes animées → campagnes TikTok natives à haute rétention.</a:t>
+              <a:t>Reportages + satellites multilingues sans diluer les comptes officiels.</a:t>
             </a:r>
             <a:endParaRPr lang="en-US" sz="1100" dirty="0"/>
           </a:p>
@@ -3278,7 +3228,7 @@
                 <a:ea typeface="Calibri" pitchFamily="34" charset="-122"/>
                 <a:cs typeface="Calibri" pitchFamily="34" charset="-120"/>
               </a:rPr>
-              <a:t>Patrimoine, mode et artisanat → essais vidéo 9:16</a:t>
+              <a:t>Le montage vidéo IA qui fonctionne enfin</a:t>
             </a:r>
             <a:endParaRPr lang="en-US" sz="1300" dirty="0"/>
           </a:p>
@@ -3317,7 +3267,24 @@
                 <a:ea typeface="Georgia" pitchFamily="34" charset="-122"/>
                 <a:cs typeface="Georgia" pitchFamily="34" charset="-120"/>
               </a:rPr>
-              <a:t>« Une Presse Gutenberg de l'ère verticale. »</a:t>
+              <a:t>« Pour les marques</a:t>
+            </a:r>
+            <a:endParaRPr lang="en-US" sz="2200" dirty="0"/>
+          </a:p>
+          <a:p>
+            <a:pPr indent="0" marL="0">
+              <a:buNone/>
+            </a:pPr>
+            <a:r>
+              <a:rPr lang="en-US" sz="2200" i="1" dirty="0">
+                <a:solidFill>
+                  <a:srgbClr val="B85042"/>
+                </a:solidFill>
+                <a:latin typeface="Georgia" pitchFamily="34" charset="0"/>
+                <a:ea typeface="Georgia" pitchFamily="34" charset="-122"/>
+                <a:cs typeface="Georgia" pitchFamily="34" charset="-120"/>
+              </a:rPr>
+              <a:t>au cahier des charges élevé. »</a:t>
             </a:r>
             <a:endParaRPr lang="en-US" sz="2200" dirty="0"/>
           </a:p>
@@ -3356,7 +3323,7 @@
                 <a:ea typeface="Calibri" pitchFamily="34" charset="-122"/>
                 <a:cs typeface="Calibri" pitchFamily="34" charset="-120"/>
               </a:rPr>
-              <a:t>CraftCut compile variables culturelles, artistiques et historiques en essais vidéo verticaux haute fidélité.</a:t>
+              <a:t>Synthèse du meilleur motion design — beat-sync, typographie suisse, grain organique.</a:t>
             </a:r>
             <a:endParaRPr lang="en-US" sz="1200" dirty="0"/>
           </a:p>
@@ -3373,7 +3340,7 @@
                 <a:ea typeface="Calibri" pitchFamily="34" charset="-122"/>
                 <a:cs typeface="Calibri" pitchFamily="34" charset="-120"/>
               </a:rPr>
-              <a:t>Pochettes animées, haute couture, plans d'architecte, geste des Ouvriers de France.</a:t>
+              <a:t>Contrôle total des sous-titres. Pipeline validé, prêt au déploiement cloud.</a:t>
             </a:r>
             <a:endParaRPr lang="en-US" sz="1200" dirty="0"/>
           </a:p>
@@ -3390,7 +3357,7 @@
                 <a:ea typeface="Calibri" pitchFamily="34" charset="-122"/>
                 <a:cs typeface="Calibri" pitchFamily="34" charset="-120"/>
               </a:rPr>
-              <a:t>Centaines de chaînes thématiques ciblées — qualité broadcast, souveraineté totale.</a:t>
+              <a:t>350 vidéos/jour · 64,3M tokens/mois.</a:t>
             </a:r>
             <a:endParaRPr lang="en-US" sz="1200" dirty="0"/>
           </a:p>
@@ -3536,7 +3503,7 @@
                 <a:ea typeface="Calibri" pitchFamily="34" charset="-122"/>
                 <a:cs typeface="Calibri" pitchFamily="34" charset="-120"/>
               </a:rPr>
-              <a:t>La dilution du prestige par le « AI slop »</a:t>
+              <a:t>Trois blocages pour les marques exigeantes</a:t>
             </a:r>
             <a:endParaRPr lang="en-US" sz="1300" dirty="0"/>
           </a:p>
@@ -3625,7 +3592,7 @@
                 <a:ea typeface="Georgia" pitchFamily="34" charset="-122"/>
                 <a:cs typeface="Georgia" pitchFamily="34" charset="-120"/>
               </a:rPr>
-              <a:t>Spam algorithmique</a:t>
+              <a:t>Cahier des charges</a:t>
             </a:r>
             <a:endParaRPr lang="en-US" sz="1400" dirty="0"/>
           </a:p>
@@ -3664,7 +3631,7 @@
                 <a:ea typeface="Calibri" pitchFamily="34" charset="-122"/>
                 <a:cs typeface="Calibri" pitchFamily="34" charset="-120"/>
               </a:rPr>
-              <a:t>Vidéos IA génériques, répétitives, basse fidélité — les plateformes les suppriment.</a:t>
+              <a:t>Le montage vidéo IA générique ne tient pas les standards motion design premium.</a:t>
             </a:r>
             <a:endParaRPr lang="en-US" sz="1100" dirty="0"/>
           </a:p>
@@ -3753,7 +3720,7 @@
                 <a:ea typeface="Georgia" pitchFamily="34" charset="-122"/>
                 <a:cs typeface="Georgia" pitchFamily="34" charset="-120"/>
               </a:rPr>
-              <a:t>Patrimoine invisible</a:t>
+              <a:t>Engagement quotidien</a:t>
             </a:r>
             <a:endParaRPr lang="en-US" sz="1400" dirty="0"/>
           </a:p>
@@ -3792,7 +3759,7 @@
                 <a:ea typeface="Calibri" pitchFamily="34" charset="-122"/>
                 <a:cs typeface="Calibri" pitchFamily="34" charset="-120"/>
               </a:rPr>
-              <a:t>L'artisanat français et le geste noble des Ouvriers restent hors du format mobile.</a:t>
+              <a:t>Entre le reportage hebdo et le flux social, aucune couche de vidéos qui développent les messages.</a:t>
             </a:r>
             <a:endParaRPr lang="en-US" sz="1100" dirty="0"/>
           </a:p>
@@ -3881,7 +3848,7 @@
                 <a:ea typeface="Georgia" pitchFamily="34" charset="-122"/>
                 <a:cs typeface="Georgia" pitchFamily="34" charset="-120"/>
               </a:rPr>
-              <a:t>Scalabilité impossible</a:t>
+              <a:t>Dilution des stats</a:t>
             </a:r>
             <a:endParaRPr lang="en-US" sz="1400" dirty="0"/>
           </a:p>
@@ -3920,7 +3887,7 @@
                 <a:ea typeface="Calibri" pitchFamily="34" charset="-122"/>
                 <a:cs typeface="Calibri" pitchFamily="34" charset="-120"/>
               </a:rPr>
-              <a:t>Les maisons de luxe ne peuvent pas produire 350 variantes localisées par jour.</a:t>
+              <a:t>Les marques hésitent à publier en plusieurs langues sur leurs comptes officiels.</a:t>
             </a:r>
             <a:endParaRPr lang="en-US" sz="1100" dirty="0"/>
           </a:p>
@@ -4066,7 +4033,7 @@
                 <a:ea typeface="Calibri" pitchFamily="34" charset="-122"/>
                 <a:cs typeface="Calibri" pitchFamily="34" charset="-120"/>
               </a:rPr>
-              <a:t>Pipeline propriétaire CraftCut</a:t>
+              <a:t>Une promesse créative tenue par l'IA</a:t>
             </a:r>
             <a:endParaRPr lang="en-US" sz="1300" dirty="0"/>
           </a:p>
@@ -4130,7 +4097,7 @@
                 <a:ea typeface="Calibri" pitchFamily="34" charset="-122"/>
                 <a:cs typeface="Calibri" pitchFamily="34" charset="-120"/>
               </a:rPr>
-              <a:t>Presse d'impression vidéo verticale autonome</a:t>
+              <a:t>Industrialiser l'excellence du motion design</a:t>
             </a:r>
             <a:endParaRPr lang="en-US" sz="1300" dirty="0"/>
           </a:p>
@@ -4147,7 +4114,7 @@
                 <a:ea typeface="Calibri" pitchFamily="34" charset="-122"/>
                 <a:cs typeface="Calibri" pitchFamily="34" charset="-120"/>
               </a:rPr>
-              <a:t>Sourcing → Localisation → Typographie → Compilation HEVC</a:t>
+              <a:t>Contrôle total des sous-titres — calage, glyphes, safe-zones, zéro collision UI</a:t>
             </a:r>
             <a:endParaRPr lang="en-US" sz="1300" dirty="0"/>
           </a:p>
@@ -4164,7 +4131,7 @@
                 <a:ea typeface="Calibri" pitchFamily="34" charset="-122"/>
                 <a:cs typeface="Calibri" pitchFamily="34" charset="-120"/>
               </a:rPr>
-              <a:t>50 campagnes/jour × 7 langues = 350 vidéos finalisées</a:t>
+              <a:t>Pipeline validé · Prêt au déploiement cloud</a:t>
             </a:r>
             <a:endParaRPr lang="en-US" sz="1300" dirty="0"/>
           </a:p>
@@ -4181,7 +4148,7 @@
                 <a:ea typeface="Calibri" pitchFamily="34" charset="-122"/>
                 <a:cs typeface="Calibri" pitchFamily="34" charset="-120"/>
               </a:rPr>
-              <a:t>Standards Canal+ : typographie suisse, zones de sécurité, grain organique</a:t>
+              <a:t>50 campagnes/jour × 7 langues = 350 vidéos finalisées</a:t>
             </a:r>
             <a:endParaRPr lang="en-US" sz="1300" dirty="0"/>
           </a:p>
@@ -4401,7 +4368,7 @@
                 <a:ea typeface="Georgia" pitchFamily="34" charset="-122"/>
                 <a:cs typeface="Georgia" pitchFamily="34" charset="-120"/>
               </a:rPr>
-              <a:t>Agent de sourcing</a:t>
+              <a:t>Porte d'entrée</a:t>
             </a:r>
             <a:endParaRPr lang="en-US" sz="3400" dirty="0"/>
           </a:p>
@@ -4440,7 +4407,7 @@
                 <a:ea typeface="Calibri" pitchFamily="34" charset="-122"/>
                 <a:cs typeface="Calibri" pitchFamily="34" charset="-120"/>
               </a:rPr>
-              <a:t>Mining automatique d'actifs motion</a:t>
+              <a:t>Pop culture → Labels → Podcasts jeunesse</a:t>
             </a:r>
             <a:endParaRPr lang="en-US" sz="1300" dirty="0"/>
           </a:p>
@@ -4455,7 +4422,7 @@
         <p:spPr>
           <a:xfrm>
             <a:off x="640080" y="1828800"/>
-            <a:ext cx="3840480" cy="1097280"/>
+            <a:ext cx="2560320" cy="2286000"/>
           </a:xfrm>
           <a:prstGeom prst="rect">
             <a:avLst/>
@@ -4480,7 +4447,7 @@
         <p:spPr>
           <a:xfrm>
             <a:off x="640080" y="1828800"/>
-            <a:ext cx="64008" cy="1097280"/>
+            <a:ext cx="64008" cy="2286000"/>
           </a:xfrm>
           <a:prstGeom prst="rect">
             <a:avLst/>
@@ -4505,7 +4472,7 @@
         <p:spPr>
           <a:xfrm>
             <a:off x="841248" y="1993392"/>
-            <a:ext cx="3520440" cy="320040"/>
+            <a:ext cx="2240280" cy="320040"/>
           </a:xfrm>
           <a:prstGeom prst="rect">
             <a:avLst/>
@@ -4529,7 +4496,7 @@
                 <a:ea typeface="Georgia" pitchFamily="34" charset="-122"/>
                 <a:cs typeface="Georgia" pitchFamily="34" charset="-120"/>
               </a:rPr>
-              <a:t>Apple Music &amp; Design Registers</a:t>
+              <a:t>Phase 1 — Pop culture</a:t>
             </a:r>
             <a:endParaRPr lang="en-US" sz="1400" dirty="0"/>
           </a:p>
@@ -4544,7 +4511,7 @@
         <p:spPr>
           <a:xfrm>
             <a:off x="841248" y="2331720"/>
-            <a:ext cx="3520440" cy="457200"/>
+            <a:ext cx="2240280" cy="1645920"/>
           </a:xfrm>
           <a:prstGeom prst="rect">
             <a:avLst/>
@@ -4568,7 +4535,7 @@
                 <a:ea typeface="Calibri" pitchFamily="34" charset="-122"/>
                 <a:cs typeface="Calibri" pitchFamily="34" charset="-120"/>
               </a:rPr>
-              <a:t>Surveillance des pochettes animées et registres de design haute résolution.</a:t>
+              <a:t>Couvertures d'album et univers artistiques : vecteur naturel pour engager artistes et labels.</a:t>
             </a:r>
             <a:endParaRPr lang="en-US" sz="1100" dirty="0"/>
           </a:p>
@@ -4582,8 +4549,8 @@
         </p:nvSpPr>
         <p:spPr>
           <a:xfrm>
-            <a:off x="640080" y="3108960"/>
-            <a:ext cx="3840480" cy="1097280"/>
+            <a:off x="3383280" y="1828800"/>
+            <a:ext cx="2560320" cy="2286000"/>
           </a:xfrm>
           <a:prstGeom prst="rect">
             <a:avLst/>
@@ -4607,8 +4574,8 @@
         </p:nvSpPr>
         <p:spPr>
           <a:xfrm>
-            <a:off x="640080" y="3108960"/>
-            <a:ext cx="64008" cy="1097280"/>
+            <a:off x="3383280" y="1828800"/>
+            <a:ext cx="64008" cy="2286000"/>
           </a:xfrm>
           <a:prstGeom prst="rect">
             <a:avLst/>
@@ -4632,8 +4599,8 @@
         </p:nvSpPr>
         <p:spPr>
           <a:xfrm>
-            <a:off x="841248" y="3273552"/>
-            <a:ext cx="3520440" cy="320040"/>
+            <a:off x="3584448" y="1993392"/>
+            <a:ext cx="2240280" cy="320040"/>
           </a:xfrm>
           <a:prstGeom prst="rect">
             <a:avLst/>
@@ -4657,7 +4624,7 @@
                 <a:ea typeface="Georgia" pitchFamily="34" charset="-122"/>
                 <a:cs typeface="Georgia" pitchFamily="34" charset="-120"/>
               </a:rPr>
-              <a:t>Rejet des placeholders</a:t>
+              <a:t>Phase 2 — Labels &amp; artistes</a:t>
             </a:r>
             <a:endParaRPr lang="en-US" sz="1400" dirty="0"/>
           </a:p>
@@ -4671,8 +4638,8 @@
         </p:nvSpPr>
         <p:spPr>
           <a:xfrm>
-            <a:off x="841248" y="3611880"/>
-            <a:ext cx="3520440" cy="457200"/>
+            <a:off x="3584448" y="2331720"/>
+            <a:ext cx="2240280" cy="1645920"/>
           </a:xfrm>
           <a:prstGeom prst="rect">
             <a:avLst/>
@@ -4696,7 +4663,7 @@
                 <a:ea typeface="Calibri" pitchFamily="34" charset="-122"/>
                 <a:cs typeface="Calibri" pitchFamily="34" charset="-120"/>
               </a:rPr>
-              <a:t>Filtrage automatique des actifs statiques — uniquement du motion vérifié.</a:t>
+              <a:t>Chaînes verticales de niche à haute rétention autour des univers musicaux.</a:t>
             </a:r>
             <a:endParaRPr lang="en-US" sz="1100" dirty="0"/>
           </a:p>
@@ -4710,8 +4677,8 @@
         </p:nvSpPr>
         <p:spPr>
           <a:xfrm>
-            <a:off x="4754880" y="1828800"/>
-            <a:ext cx="3931920" cy="2377440"/>
+            <a:off x="6126480" y="1828800"/>
+            <a:ext cx="2560320" cy="2286000"/>
           </a:xfrm>
           <a:prstGeom prst="rect">
             <a:avLst/>
@@ -4735,8 +4702,8 @@
         </p:nvSpPr>
         <p:spPr>
           <a:xfrm>
-            <a:off x="4754880" y="1828800"/>
-            <a:ext cx="64008" cy="2377440"/>
+            <a:off x="6126480" y="1828800"/>
+            <a:ext cx="64008" cy="2286000"/>
           </a:xfrm>
           <a:prstGeom prst="rect">
             <a:avLst/>
@@ -4760,8 +4727,8 @@
         </p:nvSpPr>
         <p:spPr>
           <a:xfrm>
-            <a:off x="4956048" y="1993392"/>
-            <a:ext cx="3611880" cy="320040"/>
+            <a:off x="6327648" y="1993392"/>
+            <a:ext cx="2240280" cy="320040"/>
           </a:xfrm>
           <a:prstGeom prst="rect">
             <a:avLst/>
@@ -4785,7 +4752,7 @@
                 <a:ea typeface="Georgia" pitchFamily="34" charset="-122"/>
                 <a:cs typeface="Georgia" pitchFamily="34" charset="-120"/>
               </a:rPr>
-              <a:t>Deep Web Sourcing</a:t>
+              <a:t>Phase 3 — Podcasts jeunesse</a:t>
             </a:r>
             <a:endParaRPr lang="en-US" sz="1400" dirty="0"/>
           </a:p>
@@ -4799,8 +4766,8 @@
         </p:nvSpPr>
         <p:spPr>
           <a:xfrm>
-            <a:off x="4956048" y="2331720"/>
-            <a:ext cx="3611880" cy="1737360"/>
+            <a:off x="6327648" y="2331720"/>
+            <a:ext cx="2240280" cy="1645920"/>
           </a:xfrm>
           <a:prstGeom prst="rect">
             <a:avLst/>
@@ -4824,7 +4791,7 @@
                 <a:ea typeface="Calibri" pitchFamily="34" charset="-122"/>
                 <a:cs typeface="Calibri" pitchFamily="34" charset="-120"/>
               </a:rPr>
-              <a:t>15 000 tokens d'input par cycle — catalogues mode, archives artisanales, historiques.</a:t>
+              <a:t>Extension vers formats longs ciblés jeunesse, portés par la crédibilité acquise.</a:t>
             </a:r>
             <a:endParaRPr lang="en-US" sz="1100" dirty="0"/>
           </a:p>
@@ -4931,7 +4898,7 @@
                 <a:ea typeface="Georgia" pitchFamily="34" charset="-122"/>
                 <a:cs typeface="Georgia" pitchFamily="34" charset="-120"/>
               </a:rPr>
-              <a:t>Agent de localisation</a:t>
+              <a:t>Duo éditorial</a:t>
             </a:r>
             <a:endParaRPr lang="en-US" sz="3400" dirty="0"/>
           </a:p>
@@ -4970,759 +4937,271 @@
                 <a:ea typeface="Calibri" pitchFamily="34" charset="-122"/>
                 <a:cs typeface="Calibri" pitchFamily="34" charset="-120"/>
               </a:rPr>
-              <a:t>Bornage dynamique des mots — 7 langues</a:t>
+              <a:t>Reportages hebdo + vidéos quotidiennes</a:t>
             </a:r>
             <a:endParaRPr lang="en-US" sz="1300" dirty="0"/>
           </a:p>
         </p:txBody>
       </p:sp>
-      <p:graphicFrame>
-        <p:nvGraphicFramePr>
-          <p:cNvPr id="7" name="Table 0"/>
-          <p:cNvGraphicFramePr>
-            <a:graphicFrameLocks noGrp="1"/>
-          </p:cNvGraphicFramePr>
-          <p:nvPr>
-            <p:extLst>
-              <p:ext uri="{D42A27DB-BD31-4B8C-83A1-F6EECF244321}">
-                <p14:modId xmlns:p14="http://schemas.microsoft.com/office/powerpoint/2010/main" val="1579011935"/>
-              </p:ext>
-            </p:extLst>
-          </p:nvPr>
-        </p:nvGraphicFramePr>
-        <p:xfrm>
-          <a:off x="640080" y="1828800"/>
-          <a:ext cx="8046720" cy="2011680"/>
-        </p:xfrm>
-        <a:graphic>
-          <a:graphicData uri="http://schemas.openxmlformats.org/drawingml/2006/table">
-            <a:tbl>
-              <a:tblPr/>
-              <a:tblGrid>
-                <a:gridCol w="3200400"/>
-                <a:gridCol w="2286000"/>
-                <a:gridCol w="2560320"/>
-              </a:tblGrid>
-              <a:tr h="502920">
-                <a:tc>
-                  <a:txBody>
-                    <a:bodyPr/>
-                    <a:lstStyle/>
-                    <a:p>
-                      <a:pPr indent="0" marL="0">
-                        <a:buNone/>
-                      </a:pPr>
-                      <a:r>
-                        <a:rPr lang="en-US" sz="1100" b="1" dirty="0">
-                          <a:solidFill>
-                            <a:srgbClr val="1A1A19"/>
-                          </a:solidFill>
-                        </a:rPr>
-                        <a:t>Langue</a:t>
-                      </a:r>
-                      <a:endParaRPr lang="en-US" sz="1100" dirty="0"/>
-                    </a:p>
-                  </a:txBody>
-                  <a:tcPr marL="73152" marR="73152" marT="73152" marB="73152">
-                    <a:lnL w="6350" cap="flat" cmpd="sng" algn="ctr">
-                      <a:solidFill>
-                        <a:srgbClr val="D8D8D4"/>
-                      </a:solidFill>
-                      <a:prstDash val="solid"/>
-                      <a:round/>
-                      <a:headEnd type="none" w="med" len="med"/>
-                      <a:tailEnd type="none" w="med" len="med"/>
-                    </a:lnL>
-                    <a:lnR w="6350" cap="flat" cmpd="sng" algn="ctr">
-                      <a:solidFill>
-                        <a:srgbClr val="D8D8D4"/>
-                      </a:solidFill>
-                      <a:prstDash val="solid"/>
-                      <a:round/>
-                      <a:headEnd type="none" w="med" len="med"/>
-                      <a:tailEnd type="none" w="med" len="med"/>
-                    </a:lnR>
-                    <a:lnT w="6350" cap="flat" cmpd="sng" algn="ctr">
-                      <a:solidFill>
-                        <a:srgbClr val="D8D8D4"/>
-                      </a:solidFill>
-                      <a:prstDash val="solid"/>
-                      <a:round/>
-                      <a:headEnd type="none" w="med" len="med"/>
-                      <a:tailEnd type="none" w="med" len="med"/>
-                    </a:lnT>
-                    <a:lnB w="6350" cap="flat" cmpd="sng" algn="ctr">
-                      <a:solidFill>
-                        <a:srgbClr val="D8D8D4"/>
-                      </a:solidFill>
-                      <a:prstDash val="solid"/>
-                      <a:round/>
-                      <a:headEnd type="none" w="med" len="med"/>
-                      <a:tailEnd type="none" w="med" len="med"/>
-                    </a:lnB>
-                    <a:solidFill>
-                      <a:srgbClr val="E7E8D1"/>
-                    </a:solidFill>
-                  </a:tcPr>
-                </a:tc>
-                <a:tc>
-                  <a:txBody>
-                    <a:bodyPr/>
-                    <a:lstStyle/>
-                    <a:p>
-                      <a:pPr indent="0" marL="0">
-                        <a:buNone/>
-                      </a:pPr>
-                      <a:r>
-                        <a:rPr lang="en-US" sz="1100" b="1" dirty="0">
-                          <a:solidFill>
-                            <a:srgbClr val="1A1A19"/>
-                          </a:solidFill>
-                        </a:rPr>
-                        <a:t>Limite mots</a:t>
-                      </a:r>
-                      <a:endParaRPr lang="en-US" sz="1100" dirty="0"/>
-                    </a:p>
-                  </a:txBody>
-                  <a:tcPr marL="73152" marR="73152" marT="73152" marB="73152">
-                    <a:lnL w="6350" cap="flat" cmpd="sng" algn="ctr">
-                      <a:solidFill>
-                        <a:srgbClr val="D8D8D4"/>
-                      </a:solidFill>
-                      <a:prstDash val="solid"/>
-                      <a:round/>
-                      <a:headEnd type="none" w="med" len="med"/>
-                      <a:tailEnd type="none" w="med" len="med"/>
-                    </a:lnL>
-                    <a:lnR w="6350" cap="flat" cmpd="sng" algn="ctr">
-                      <a:solidFill>
-                        <a:srgbClr val="D8D8D4"/>
-                      </a:solidFill>
-                      <a:prstDash val="solid"/>
-                      <a:round/>
-                      <a:headEnd type="none" w="med" len="med"/>
-                      <a:tailEnd type="none" w="med" len="med"/>
-                    </a:lnR>
-                    <a:lnT w="6350" cap="flat" cmpd="sng" algn="ctr">
-                      <a:solidFill>
-                        <a:srgbClr val="D8D8D4"/>
-                      </a:solidFill>
-                      <a:prstDash val="solid"/>
-                      <a:round/>
-                      <a:headEnd type="none" w="med" len="med"/>
-                      <a:tailEnd type="none" w="med" len="med"/>
-                    </a:lnT>
-                    <a:lnB w="6350" cap="flat" cmpd="sng" algn="ctr">
-                      <a:solidFill>
-                        <a:srgbClr val="D8D8D4"/>
-                      </a:solidFill>
-                      <a:prstDash val="solid"/>
-                      <a:round/>
-                      <a:headEnd type="none" w="med" len="med"/>
-                      <a:tailEnd type="none" w="med" len="med"/>
-                    </a:lnB>
-                    <a:solidFill>
-                      <a:srgbClr val="E7E8D1"/>
-                    </a:solidFill>
-                  </a:tcPr>
-                </a:tc>
-                <a:tc>
-                  <a:txBody>
-                    <a:bodyPr/>
-                    <a:lstStyle/>
-                    <a:p>
-                      <a:pPr indent="0" marL="0">
-                        <a:buNone/>
-                      </a:pPr>
-                      <a:r>
-                        <a:rPr lang="en-US" sz="1100" b="1" dirty="0">
-                          <a:solidFill>
-                            <a:srgbClr val="1A1A19"/>
-                          </a:solidFill>
-                        </a:rPr>
-                        <a:t>Durée max</a:t>
-                      </a:r>
-                      <a:endParaRPr lang="en-US" sz="1100" dirty="0"/>
-                    </a:p>
-                  </a:txBody>
-                  <a:tcPr marL="73152" marR="73152" marT="73152" marB="73152">
-                    <a:lnL w="6350" cap="flat" cmpd="sng" algn="ctr">
-                      <a:solidFill>
-                        <a:srgbClr val="D8D8D4"/>
-                      </a:solidFill>
-                      <a:prstDash val="solid"/>
-                      <a:round/>
-                      <a:headEnd type="none" w="med" len="med"/>
-                      <a:tailEnd type="none" w="med" len="med"/>
-                    </a:lnL>
-                    <a:lnR w="6350" cap="flat" cmpd="sng" algn="ctr">
-                      <a:solidFill>
-                        <a:srgbClr val="D8D8D4"/>
-                      </a:solidFill>
-                      <a:prstDash val="solid"/>
-                      <a:round/>
-                      <a:headEnd type="none" w="med" len="med"/>
-                      <a:tailEnd type="none" w="med" len="med"/>
-                    </a:lnR>
-                    <a:lnT w="6350" cap="flat" cmpd="sng" algn="ctr">
-                      <a:solidFill>
-                        <a:srgbClr val="D8D8D4"/>
-                      </a:solidFill>
-                      <a:prstDash val="solid"/>
-                      <a:round/>
-                      <a:headEnd type="none" w="med" len="med"/>
-                      <a:tailEnd type="none" w="med" len="med"/>
-                    </a:lnT>
-                    <a:lnB w="6350" cap="flat" cmpd="sng" algn="ctr">
-                      <a:solidFill>
-                        <a:srgbClr val="D8D8D4"/>
-                      </a:solidFill>
-                      <a:prstDash val="solid"/>
-                      <a:round/>
-                      <a:headEnd type="none" w="med" len="med"/>
-                      <a:tailEnd type="none" w="med" len="med"/>
-                    </a:lnB>
-                    <a:solidFill>
-                      <a:srgbClr val="E7E8D1"/>
-                    </a:solidFill>
-                  </a:tcPr>
-                </a:tc>
-              </a:tr>
-              <a:tr h="502920">
-                <a:tc>
-                  <a:txBody>
-                    <a:bodyPr/>
-                    <a:lstStyle/>
-                    <a:p>
-                      <a:pPr indent="0" marL="0">
-                        <a:buNone/>
-                      </a:pPr>
-                      <a:r>
-                        <a:rPr lang="en-US" sz="1100" dirty="0">
-                          <a:solidFill>
-                            <a:srgbClr val="1A1A19"/>
-                          </a:solidFill>
-                        </a:rPr>
-                        <a:t>FR / EN / ES / IT / PT / LV</a:t>
-                      </a:r>
-                      <a:endParaRPr lang="en-US" sz="1100" dirty="0"/>
-                    </a:p>
-                  </a:txBody>
-                  <a:tcPr marL="73152" marR="73152" marT="73152" marB="73152">
-                    <a:lnL w="6350" cap="flat" cmpd="sng" algn="ctr">
-                      <a:solidFill>
-                        <a:srgbClr val="D8D8D4"/>
-                      </a:solidFill>
-                      <a:prstDash val="solid"/>
-                      <a:round/>
-                      <a:headEnd type="none" w="med" len="med"/>
-                      <a:tailEnd type="none" w="med" len="med"/>
-                    </a:lnL>
-                    <a:lnR w="6350" cap="flat" cmpd="sng" algn="ctr">
-                      <a:solidFill>
-                        <a:srgbClr val="D8D8D4"/>
-                      </a:solidFill>
-                      <a:prstDash val="solid"/>
-                      <a:round/>
-                      <a:headEnd type="none" w="med" len="med"/>
-                      <a:tailEnd type="none" w="med" len="med"/>
-                    </a:lnR>
-                    <a:lnT w="6350" cap="flat" cmpd="sng" algn="ctr">
-                      <a:solidFill>
-                        <a:srgbClr val="D8D8D4"/>
-                      </a:solidFill>
-                      <a:prstDash val="solid"/>
-                      <a:round/>
-                      <a:headEnd type="none" w="med" len="med"/>
-                      <a:tailEnd type="none" w="med" len="med"/>
-                    </a:lnT>
-                    <a:lnB w="6350" cap="flat" cmpd="sng" algn="ctr">
-                      <a:solidFill>
-                        <a:srgbClr val="D8D8D4"/>
-                      </a:solidFill>
-                      <a:prstDash val="solid"/>
-                      <a:round/>
-                      <a:headEnd type="none" w="med" len="med"/>
-                      <a:tailEnd type="none" w="med" len="med"/>
-                    </a:lnB>
-                  </a:tcPr>
-                </a:tc>
-                <a:tc>
-                  <a:txBody>
-                    <a:bodyPr/>
-                    <a:lstStyle/>
-                    <a:p>
-                      <a:pPr indent="0" marL="0">
-                        <a:buNone/>
-                      </a:pPr>
-                      <a:r>
-                        <a:rPr lang="en-US" sz="1100" dirty="0">
-                          <a:solidFill>
-                            <a:srgbClr val="1A1A19"/>
-                          </a:solidFill>
-                        </a:rPr>
-                        <a:t>120 mots</a:t>
-                      </a:r>
-                      <a:endParaRPr lang="en-US" sz="1100" dirty="0"/>
-                    </a:p>
-                  </a:txBody>
-                  <a:tcPr marL="73152" marR="73152" marT="73152" marB="73152">
-                    <a:lnL w="6350" cap="flat" cmpd="sng" algn="ctr">
-                      <a:solidFill>
-                        <a:srgbClr val="D8D8D4"/>
-                      </a:solidFill>
-                      <a:prstDash val="solid"/>
-                      <a:round/>
-                      <a:headEnd type="none" w="med" len="med"/>
-                      <a:tailEnd type="none" w="med" len="med"/>
-                    </a:lnL>
-                    <a:lnR w="6350" cap="flat" cmpd="sng" algn="ctr">
-                      <a:solidFill>
-                        <a:srgbClr val="D8D8D4"/>
-                      </a:solidFill>
-                      <a:prstDash val="solid"/>
-                      <a:round/>
-                      <a:headEnd type="none" w="med" len="med"/>
-                      <a:tailEnd type="none" w="med" len="med"/>
-                    </a:lnR>
-                    <a:lnT w="6350" cap="flat" cmpd="sng" algn="ctr">
-                      <a:solidFill>
-                        <a:srgbClr val="D8D8D4"/>
-                      </a:solidFill>
-                      <a:prstDash val="solid"/>
-                      <a:round/>
-                      <a:headEnd type="none" w="med" len="med"/>
-                      <a:tailEnd type="none" w="med" len="med"/>
-                    </a:lnT>
-                    <a:lnB w="6350" cap="flat" cmpd="sng" algn="ctr">
-                      <a:solidFill>
-                        <a:srgbClr val="D8D8D4"/>
-                      </a:solidFill>
-                      <a:prstDash val="solid"/>
-                      <a:round/>
-                      <a:headEnd type="none" w="med" len="med"/>
-                      <a:tailEnd type="none" w="med" len="med"/>
-                    </a:lnB>
-                  </a:tcPr>
-                </a:tc>
-                <a:tc>
-                  <a:txBody>
-                    <a:bodyPr/>
-                    <a:lstStyle/>
-                    <a:p>
-                      <a:pPr indent="0" marL="0">
-                        <a:buNone/>
-                      </a:pPr>
-                      <a:r>
-                        <a:rPr lang="en-US" sz="1100" dirty="0">
-                          <a:solidFill>
-                            <a:srgbClr val="1A1A19"/>
-                          </a:solidFill>
-                        </a:rPr>
-                        <a:t>60 sec</a:t>
-                      </a:r>
-                      <a:endParaRPr lang="en-US" sz="1100" dirty="0"/>
-                    </a:p>
-                  </a:txBody>
-                  <a:tcPr marL="73152" marR="73152" marT="73152" marB="73152">
-                    <a:lnL w="6350" cap="flat" cmpd="sng" algn="ctr">
-                      <a:solidFill>
-                        <a:srgbClr val="D8D8D4"/>
-                      </a:solidFill>
-                      <a:prstDash val="solid"/>
-                      <a:round/>
-                      <a:headEnd type="none" w="med" len="med"/>
-                      <a:tailEnd type="none" w="med" len="med"/>
-                    </a:lnL>
-                    <a:lnR w="6350" cap="flat" cmpd="sng" algn="ctr">
-                      <a:solidFill>
-                        <a:srgbClr val="D8D8D4"/>
-                      </a:solidFill>
-                      <a:prstDash val="solid"/>
-                      <a:round/>
-                      <a:headEnd type="none" w="med" len="med"/>
-                      <a:tailEnd type="none" w="med" len="med"/>
-                    </a:lnR>
-                    <a:lnT w="6350" cap="flat" cmpd="sng" algn="ctr">
-                      <a:solidFill>
-                        <a:srgbClr val="D8D8D4"/>
-                      </a:solidFill>
-                      <a:prstDash val="solid"/>
-                      <a:round/>
-                      <a:headEnd type="none" w="med" len="med"/>
-                      <a:tailEnd type="none" w="med" len="med"/>
-                    </a:lnT>
-                    <a:lnB w="6350" cap="flat" cmpd="sng" algn="ctr">
-                      <a:solidFill>
-                        <a:srgbClr val="D8D8D4"/>
-                      </a:solidFill>
-                      <a:prstDash val="solid"/>
-                      <a:round/>
-                      <a:headEnd type="none" w="med" len="med"/>
-                      <a:tailEnd type="none" w="med" len="med"/>
-                    </a:lnB>
-                  </a:tcPr>
-                </a:tc>
-              </a:tr>
-              <a:tr h="502920">
-                <a:tc>
-                  <a:txBody>
-                    <a:bodyPr/>
-                    <a:lstStyle/>
-                    <a:p>
-                      <a:pPr indent="0" marL="0">
-                        <a:buNone/>
-                      </a:pPr>
-                      <a:r>
-                        <a:rPr lang="en-US" sz="1100" dirty="0">
-                          <a:solidFill>
-                            <a:srgbClr val="1A1A19"/>
-                          </a:solidFill>
-                        </a:rPr>
-                        <a:t>DE</a:t>
-                      </a:r>
-                      <a:endParaRPr lang="en-US" sz="1100" dirty="0"/>
-                    </a:p>
-                  </a:txBody>
-                  <a:tcPr marL="73152" marR="73152" marT="73152" marB="73152">
-                    <a:lnL w="6350" cap="flat" cmpd="sng" algn="ctr">
-                      <a:solidFill>
-                        <a:srgbClr val="D8D8D4"/>
-                      </a:solidFill>
-                      <a:prstDash val="solid"/>
-                      <a:round/>
-                      <a:headEnd type="none" w="med" len="med"/>
-                      <a:tailEnd type="none" w="med" len="med"/>
-                    </a:lnL>
-                    <a:lnR w="6350" cap="flat" cmpd="sng" algn="ctr">
-                      <a:solidFill>
-                        <a:srgbClr val="D8D8D4"/>
-                      </a:solidFill>
-                      <a:prstDash val="solid"/>
-                      <a:round/>
-                      <a:headEnd type="none" w="med" len="med"/>
-                      <a:tailEnd type="none" w="med" len="med"/>
-                    </a:lnR>
-                    <a:lnT w="6350" cap="flat" cmpd="sng" algn="ctr">
-                      <a:solidFill>
-                        <a:srgbClr val="D8D8D4"/>
-                      </a:solidFill>
-                      <a:prstDash val="solid"/>
-                      <a:round/>
-                      <a:headEnd type="none" w="med" len="med"/>
-                      <a:tailEnd type="none" w="med" len="med"/>
-                    </a:lnT>
-                    <a:lnB w="6350" cap="flat" cmpd="sng" algn="ctr">
-                      <a:solidFill>
-                        <a:srgbClr val="D8D8D4"/>
-                      </a:solidFill>
-                      <a:prstDash val="solid"/>
-                      <a:round/>
-                      <a:headEnd type="none" w="med" len="med"/>
-                      <a:tailEnd type="none" w="med" len="med"/>
-                    </a:lnB>
-                  </a:tcPr>
-                </a:tc>
-                <a:tc>
-                  <a:txBody>
-                    <a:bodyPr/>
-                    <a:lstStyle/>
-                    <a:p>
-                      <a:pPr indent="0" marL="0">
-                        <a:buNone/>
-                      </a:pPr>
-                      <a:r>
-                        <a:rPr lang="en-US" sz="1100" dirty="0">
-                          <a:solidFill>
-                            <a:srgbClr val="1A1A19"/>
-                          </a:solidFill>
-                        </a:rPr>
-                        <a:t>85 mots</a:t>
-                      </a:r>
-                      <a:endParaRPr lang="en-US" sz="1100" dirty="0"/>
-                    </a:p>
-                  </a:txBody>
-                  <a:tcPr marL="73152" marR="73152" marT="73152" marB="73152">
-                    <a:lnL w="6350" cap="flat" cmpd="sng" algn="ctr">
-                      <a:solidFill>
-                        <a:srgbClr val="D8D8D4"/>
-                      </a:solidFill>
-                      <a:prstDash val="solid"/>
-                      <a:round/>
-                      <a:headEnd type="none" w="med" len="med"/>
-                      <a:tailEnd type="none" w="med" len="med"/>
-                    </a:lnL>
-                    <a:lnR w="6350" cap="flat" cmpd="sng" algn="ctr">
-                      <a:solidFill>
-                        <a:srgbClr val="D8D8D4"/>
-                      </a:solidFill>
-                      <a:prstDash val="solid"/>
-                      <a:round/>
-                      <a:headEnd type="none" w="med" len="med"/>
-                      <a:tailEnd type="none" w="med" len="med"/>
-                    </a:lnR>
-                    <a:lnT w="6350" cap="flat" cmpd="sng" algn="ctr">
-                      <a:solidFill>
-                        <a:srgbClr val="D8D8D4"/>
-                      </a:solidFill>
-                      <a:prstDash val="solid"/>
-                      <a:round/>
-                      <a:headEnd type="none" w="med" len="med"/>
-                      <a:tailEnd type="none" w="med" len="med"/>
-                    </a:lnT>
-                    <a:lnB w="6350" cap="flat" cmpd="sng" algn="ctr">
-                      <a:solidFill>
-                        <a:srgbClr val="D8D8D4"/>
-                      </a:solidFill>
-                      <a:prstDash val="solid"/>
-                      <a:round/>
-                      <a:headEnd type="none" w="med" len="med"/>
-                      <a:tailEnd type="none" w="med" len="med"/>
-                    </a:lnB>
-                  </a:tcPr>
-                </a:tc>
-                <a:tc>
-                  <a:txBody>
-                    <a:bodyPr/>
-                    <a:lstStyle/>
-                    <a:p>
-                      <a:pPr indent="0" marL="0">
-                        <a:buNone/>
-                      </a:pPr>
-                      <a:r>
-                        <a:rPr lang="en-US" sz="1100" dirty="0">
-                          <a:solidFill>
-                            <a:srgbClr val="1A1A19"/>
-                          </a:solidFill>
-                        </a:rPr>
-                        <a:t>60 sec</a:t>
-                      </a:r>
-                      <a:endParaRPr lang="en-US" sz="1100" dirty="0"/>
-                    </a:p>
-                  </a:txBody>
-                  <a:tcPr marL="73152" marR="73152" marT="73152" marB="73152">
-                    <a:lnL w="6350" cap="flat" cmpd="sng" algn="ctr">
-                      <a:solidFill>
-                        <a:srgbClr val="D8D8D4"/>
-                      </a:solidFill>
-                      <a:prstDash val="solid"/>
-                      <a:round/>
-                      <a:headEnd type="none" w="med" len="med"/>
-                      <a:tailEnd type="none" w="med" len="med"/>
-                    </a:lnL>
-                    <a:lnR w="6350" cap="flat" cmpd="sng" algn="ctr">
-                      <a:solidFill>
-                        <a:srgbClr val="D8D8D4"/>
-                      </a:solidFill>
-                      <a:prstDash val="solid"/>
-                      <a:round/>
-                      <a:headEnd type="none" w="med" len="med"/>
-                      <a:tailEnd type="none" w="med" len="med"/>
-                    </a:lnR>
-                    <a:lnT w="6350" cap="flat" cmpd="sng" algn="ctr">
-                      <a:solidFill>
-                        <a:srgbClr val="D8D8D4"/>
-                      </a:solidFill>
-                      <a:prstDash val="solid"/>
-                      <a:round/>
-                      <a:headEnd type="none" w="med" len="med"/>
-                      <a:tailEnd type="none" w="med" len="med"/>
-                    </a:lnT>
-                    <a:lnB w="6350" cap="flat" cmpd="sng" algn="ctr">
-                      <a:solidFill>
-                        <a:srgbClr val="D8D8D4"/>
-                      </a:solidFill>
-                      <a:prstDash val="solid"/>
-                      <a:round/>
-                      <a:headEnd type="none" w="med" len="med"/>
-                      <a:tailEnd type="none" w="med" len="med"/>
-                    </a:lnB>
-                  </a:tcPr>
-                </a:tc>
-              </a:tr>
-              <a:tr h="502920">
-                <a:tc>
-                  <a:txBody>
-                    <a:bodyPr/>
-                    <a:lstStyle/>
-                    <a:p>
-                      <a:pPr indent="0" marL="0">
-                        <a:buNone/>
-                      </a:pPr>
-                      <a:r>
-                        <a:rPr lang="en-US" sz="1100" dirty="0">
-                          <a:solidFill>
-                            <a:srgbClr val="1A1A19"/>
-                          </a:solidFill>
-                        </a:rPr>
-                        <a:t>Consensus multi-agents</a:t>
-                      </a:r>
-                      <a:endParaRPr lang="en-US" sz="1100" dirty="0"/>
-                    </a:p>
-                  </a:txBody>
-                  <a:tcPr marL="73152" marR="73152" marT="73152" marB="73152">
-                    <a:lnL w="6350" cap="flat" cmpd="sng" algn="ctr">
-                      <a:solidFill>
-                        <a:srgbClr val="D8D8D4"/>
-                      </a:solidFill>
-                      <a:prstDash val="solid"/>
-                      <a:round/>
-                      <a:headEnd type="none" w="med" len="med"/>
-                      <a:tailEnd type="none" w="med" len="med"/>
-                    </a:lnL>
-                    <a:lnR w="6350" cap="flat" cmpd="sng" algn="ctr">
-                      <a:solidFill>
-                        <a:srgbClr val="D8D8D4"/>
-                      </a:solidFill>
-                      <a:prstDash val="solid"/>
-                      <a:round/>
-                      <a:headEnd type="none" w="med" len="med"/>
-                      <a:tailEnd type="none" w="med" len="med"/>
-                    </a:lnR>
-                    <a:lnT w="6350" cap="flat" cmpd="sng" algn="ctr">
-                      <a:solidFill>
-                        <a:srgbClr val="D8D8D4"/>
-                      </a:solidFill>
-                      <a:prstDash val="solid"/>
-                      <a:round/>
-                      <a:headEnd type="none" w="med" len="med"/>
-                      <a:tailEnd type="none" w="med" len="med"/>
-                    </a:lnT>
-                    <a:lnB w="6350" cap="flat" cmpd="sng" algn="ctr">
-                      <a:solidFill>
-                        <a:srgbClr val="D8D8D4"/>
-                      </a:solidFill>
-                      <a:prstDash val="solid"/>
-                      <a:round/>
-                      <a:headEnd type="none" w="med" len="med"/>
-                      <a:tailEnd type="none" w="med" len="med"/>
-                    </a:lnB>
-                  </a:tcPr>
-                </a:tc>
-                <a:tc>
-                  <a:txBody>
-                    <a:bodyPr/>
-                    <a:lstStyle/>
-                    <a:p>
-                      <a:pPr indent="0" marL="0">
-                        <a:buNone/>
-                      </a:pPr>
-                      <a:r>
-                        <a:rPr lang="en-US" sz="1100" dirty="0">
-                          <a:solidFill>
-                            <a:srgbClr val="1A1A19"/>
-                          </a:solidFill>
-                        </a:rPr>
-                        <a:t>12 000 tokens/output</a:t>
-                      </a:r>
-                      <a:endParaRPr lang="en-US" sz="1100" dirty="0"/>
-                    </a:p>
-                  </a:txBody>
-                  <a:tcPr marL="73152" marR="73152" marT="73152" marB="73152">
-                    <a:lnL w="6350" cap="flat" cmpd="sng" algn="ctr">
-                      <a:solidFill>
-                        <a:srgbClr val="D8D8D4"/>
-                      </a:solidFill>
-                      <a:prstDash val="solid"/>
-                      <a:round/>
-                      <a:headEnd type="none" w="med" len="med"/>
-                      <a:tailEnd type="none" w="med" len="med"/>
-                    </a:lnL>
-                    <a:lnR w="6350" cap="flat" cmpd="sng" algn="ctr">
-                      <a:solidFill>
-                        <a:srgbClr val="D8D8D4"/>
-                      </a:solidFill>
-                      <a:prstDash val="solid"/>
-                      <a:round/>
-                      <a:headEnd type="none" w="med" len="med"/>
-                      <a:tailEnd type="none" w="med" len="med"/>
-                    </a:lnR>
-                    <a:lnT w="6350" cap="flat" cmpd="sng" algn="ctr">
-                      <a:solidFill>
-                        <a:srgbClr val="D8D8D4"/>
-                      </a:solidFill>
-                      <a:prstDash val="solid"/>
-                      <a:round/>
-                      <a:headEnd type="none" w="med" len="med"/>
-                      <a:tailEnd type="none" w="med" len="med"/>
-                    </a:lnT>
-                    <a:lnB w="6350" cap="flat" cmpd="sng" algn="ctr">
-                      <a:solidFill>
-                        <a:srgbClr val="D8D8D4"/>
-                      </a:solidFill>
-                      <a:prstDash val="solid"/>
-                      <a:round/>
-                      <a:headEnd type="none" w="med" len="med"/>
-                      <a:tailEnd type="none" w="med" len="med"/>
-                    </a:lnB>
-                  </a:tcPr>
-                </a:tc>
-                <a:tc>
-                  <a:txBody>
-                    <a:bodyPr/>
-                    <a:lstStyle/>
-                    <a:p>
-                      <a:pPr indent="0" marL="0">
-                        <a:buNone/>
-                      </a:pPr>
-                      <a:r>
-                        <a:rPr lang="en-US" sz="1100" dirty="0">
-                          <a:solidFill>
-                            <a:srgbClr val="1A1A19"/>
-                          </a:solidFill>
-                        </a:rPr>
-                        <a:t>7 streams parallèles</a:t>
-                      </a:r>
-                      <a:endParaRPr lang="en-US" sz="1100" dirty="0"/>
-                    </a:p>
-                  </a:txBody>
-                  <a:tcPr marL="73152" marR="73152" marT="73152" marB="73152">
-                    <a:lnL w="6350" cap="flat" cmpd="sng" algn="ctr">
-                      <a:solidFill>
-                        <a:srgbClr val="D8D8D4"/>
-                      </a:solidFill>
-                      <a:prstDash val="solid"/>
-                      <a:round/>
-                      <a:headEnd type="none" w="med" len="med"/>
-                      <a:tailEnd type="none" w="med" len="med"/>
-                    </a:lnL>
-                    <a:lnR w="6350" cap="flat" cmpd="sng" algn="ctr">
-                      <a:solidFill>
-                        <a:srgbClr val="D8D8D4"/>
-                      </a:solidFill>
-                      <a:prstDash val="solid"/>
-                      <a:round/>
-                      <a:headEnd type="none" w="med" len="med"/>
-                      <a:tailEnd type="none" w="med" len="med"/>
-                    </a:lnR>
-                    <a:lnT w="6350" cap="flat" cmpd="sng" algn="ctr">
-                      <a:solidFill>
-                        <a:srgbClr val="D8D8D4"/>
-                      </a:solidFill>
-                      <a:prstDash val="solid"/>
-                      <a:round/>
-                      <a:headEnd type="none" w="med" len="med"/>
-                      <a:tailEnd type="none" w="med" len="med"/>
-                    </a:lnT>
-                    <a:lnB w="6350" cap="flat" cmpd="sng" algn="ctr">
-                      <a:solidFill>
-                        <a:srgbClr val="D8D8D4"/>
-                      </a:solidFill>
-                      <a:prstDash val="solid"/>
-                      <a:round/>
-                      <a:headEnd type="none" w="med" len="med"/>
-                      <a:tailEnd type="none" w="med" len="med"/>
-                    </a:lnB>
-                  </a:tcPr>
-                </a:tc>
-              </a:tr>
-            </a:tbl>
-          </a:graphicData>
-        </a:graphic>
-      </p:graphicFrame>
-      <p:sp>
-        <p:nvSpPr>
-          <p:cNvPr id="5" name="Text 2"/>
+      <p:sp>
+        <p:nvSpPr>
+          <p:cNvPr id="4" name="Shape 2"/>
+          <p:cNvSpPr/>
+          <p:nvPr/>
+        </p:nvSpPr>
+        <p:spPr>
+          <a:xfrm>
+            <a:off x="640080" y="1828800"/>
+            <a:ext cx="3840480" cy="2377440"/>
+          </a:xfrm>
+          <a:prstGeom prst="rect">
+            <a:avLst/>
+          </a:prstGeom>
+          <a:solidFill>
+            <a:srgbClr val="FFFFFF"/>
+          </a:solidFill>
+          <a:ln w="12700">
+            <a:solidFill>
+              <a:srgbClr val="D8D8D4"/>
+            </a:solidFill>
+            <a:prstDash val="solid"/>
+          </a:ln>
+        </p:spPr>
+      </p:sp>
+      <p:sp>
+        <p:nvSpPr>
+          <p:cNvPr id="5" name="Shape 3"/>
+          <p:cNvSpPr/>
+          <p:nvPr/>
+        </p:nvSpPr>
+        <p:spPr>
+          <a:xfrm>
+            <a:off x="640080" y="1828800"/>
+            <a:ext cx="64008" cy="2377440"/>
+          </a:xfrm>
+          <a:prstGeom prst="rect">
+            <a:avLst/>
+          </a:prstGeom>
+          <a:solidFill>
+            <a:srgbClr val="B85042"/>
+          </a:solidFill>
+          <a:ln w="12700">
+            <a:solidFill>
+              <a:srgbClr val="B85042"/>
+            </a:solidFill>
+            <a:prstDash val="solid"/>
+          </a:ln>
+        </p:spPr>
+      </p:sp>
+      <p:sp>
+        <p:nvSpPr>
+          <p:cNvPr id="6" name="Text 4"/>
+          <p:cNvSpPr/>
+          <p:nvPr/>
+        </p:nvSpPr>
+        <p:spPr>
+          <a:xfrm>
+            <a:off x="841248" y="1993392"/>
+            <a:ext cx="3520440" cy="320040"/>
+          </a:xfrm>
+          <a:prstGeom prst="rect">
+            <a:avLst/>
+          </a:prstGeom>
+          <a:noFill/>
+          <a:ln/>
+        </p:spPr>
+        <p:txBody>
+          <a:bodyPr wrap="square" lIns="0" tIns="0" rIns="0" bIns="0" rtlCol="0" anchor="ctr"/>
+          <a:lstStyle/>
+          <a:p>
+            <a:pPr indent="0" marL="0">
+              <a:buNone/>
+            </a:pPr>
+            <a:r>
+              <a:rPr lang="en-US" sz="1400" b="1" dirty="0">
+                <a:solidFill>
+                  <a:srgbClr val="1A1A19"/>
+                </a:solidFill>
+                <a:latin typeface="Georgia" pitchFamily="34" charset="0"/>
+                <a:ea typeface="Georgia" pitchFamily="34" charset="-122"/>
+                <a:cs typeface="Georgia" pitchFamily="34" charset="-120"/>
+              </a:rPr>
+              <a:t>Reportages hebdomadaires</a:t>
+            </a:r>
+            <a:endParaRPr lang="en-US" sz="1400" dirty="0"/>
+          </a:p>
+        </p:txBody>
+      </p:sp>
+      <p:sp>
+        <p:nvSpPr>
+          <p:cNvPr id="7" name="Text 5"/>
+          <p:cNvSpPr/>
+          <p:nvPr/>
+        </p:nvSpPr>
+        <p:spPr>
+          <a:xfrm>
+            <a:off x="841248" y="2331720"/>
+            <a:ext cx="3520440" cy="1737360"/>
+          </a:xfrm>
+          <a:prstGeom prst="rect">
+            <a:avLst/>
+          </a:prstGeom>
+          <a:noFill/>
+          <a:ln/>
+        </p:spPr>
+        <p:txBody>
+          <a:bodyPr wrap="square" lIns="0" tIns="0" rIns="0" bIns="0" rtlCol="0" anchor="t"/>
+          <a:lstStyle/>
+          <a:p>
+            <a:pPr indent="0" marL="0">
+              <a:buNone/>
+            </a:pPr>
+            <a:r>
+              <a:rPr lang="en-US" sz="1100" dirty="0">
+                <a:solidFill>
+                  <a:srgbClr val="6B6B68"/>
+                </a:solidFill>
+                <a:latin typeface="Calibri" pitchFamily="34" charset="0"/>
+                <a:ea typeface="Calibri" pitchFamily="34" charset="-122"/>
+                <a:cs typeface="Calibri" pitchFamily="34" charset="-120"/>
+              </a:rPr>
+              <a:t>Terrain, architecture, Ouvriers de France, coulisses de marque — le fond, l'authenticité, la crédibilité.</a:t>
+            </a:r>
+            <a:endParaRPr lang="en-US" sz="1100" dirty="0"/>
+          </a:p>
+        </p:txBody>
+      </p:sp>
+      <p:sp>
+        <p:nvSpPr>
+          <p:cNvPr id="8" name="Shape 6"/>
+          <p:cNvSpPr/>
+          <p:nvPr/>
+        </p:nvSpPr>
+        <p:spPr>
+          <a:xfrm>
+            <a:off x="4754880" y="1828800"/>
+            <a:ext cx="3931920" cy="2377440"/>
+          </a:xfrm>
+          <a:prstGeom prst="rect">
+            <a:avLst/>
+          </a:prstGeom>
+          <a:solidFill>
+            <a:srgbClr val="FFFFFF"/>
+          </a:solidFill>
+          <a:ln w="12700">
+            <a:solidFill>
+              <a:srgbClr val="D8D8D4"/>
+            </a:solidFill>
+            <a:prstDash val="solid"/>
+          </a:ln>
+        </p:spPr>
+      </p:sp>
+      <p:sp>
+        <p:nvSpPr>
+          <p:cNvPr id="9" name="Shape 7"/>
+          <p:cNvSpPr/>
+          <p:nvPr/>
+        </p:nvSpPr>
+        <p:spPr>
+          <a:xfrm>
+            <a:off x="4754880" y="1828800"/>
+            <a:ext cx="64008" cy="2377440"/>
+          </a:xfrm>
+          <a:prstGeom prst="rect">
+            <a:avLst/>
+          </a:prstGeom>
+          <a:solidFill>
+            <a:srgbClr val="B85042"/>
+          </a:solidFill>
+          <a:ln w="12700">
+            <a:solidFill>
+              <a:srgbClr val="B85042"/>
+            </a:solidFill>
+            <a:prstDash val="solid"/>
+          </a:ln>
+        </p:spPr>
+      </p:sp>
+      <p:sp>
+        <p:nvSpPr>
+          <p:cNvPr id="10" name="Text 8"/>
+          <p:cNvSpPr/>
+          <p:nvPr/>
+        </p:nvSpPr>
+        <p:spPr>
+          <a:xfrm>
+            <a:off x="4956048" y="1993392"/>
+            <a:ext cx="3611880" cy="320040"/>
+          </a:xfrm>
+          <a:prstGeom prst="rect">
+            <a:avLst/>
+          </a:prstGeom>
+          <a:noFill/>
+          <a:ln/>
+        </p:spPr>
+        <p:txBody>
+          <a:bodyPr wrap="square" lIns="0" tIns="0" rIns="0" bIns="0" rtlCol="0" anchor="ctr"/>
+          <a:lstStyle/>
+          <a:p>
+            <a:pPr indent="0" marL="0">
+              <a:buNone/>
+            </a:pPr>
+            <a:r>
+              <a:rPr lang="en-US" sz="1400" b="1" dirty="0">
+                <a:solidFill>
+                  <a:srgbClr val="1A1A19"/>
+                </a:solidFill>
+                <a:latin typeface="Georgia" pitchFamily="34" charset="0"/>
+                <a:ea typeface="Georgia" pitchFamily="34" charset="-122"/>
+                <a:cs typeface="Georgia" pitchFamily="34" charset="-120"/>
+              </a:rPr>
+              <a:t>Vidéos quotidiennes</a:t>
+            </a:r>
+            <a:endParaRPr lang="en-US" sz="1400" dirty="0"/>
+          </a:p>
+        </p:txBody>
+      </p:sp>
+      <p:sp>
+        <p:nvSpPr>
+          <p:cNvPr id="11" name="Text 9"/>
+          <p:cNvSpPr/>
+          <p:nvPr/>
+        </p:nvSpPr>
+        <p:spPr>
+          <a:xfrm>
+            <a:off x="4956048" y="2331720"/>
+            <a:ext cx="3611880" cy="1737360"/>
+          </a:xfrm>
+          <a:prstGeom prst="rect">
+            <a:avLst/>
+          </a:prstGeom>
+          <a:noFill/>
+          <a:ln/>
+        </p:spPr>
+        <p:txBody>
+          <a:bodyPr wrap="square" lIns="0" tIns="0" rIns="0" bIns="0" rtlCol="0" anchor="t"/>
+          <a:lstStyle/>
+          <a:p>
+            <a:pPr indent="0" marL="0">
+              <a:buNone/>
+            </a:pPr>
+            <a:r>
+              <a:rPr lang="en-US" sz="1100" dirty="0">
+                <a:solidFill>
+                  <a:srgbClr val="6B6B68"/>
+                </a:solidFill>
+                <a:latin typeface="Calibri" pitchFamily="34" charset="0"/>
+                <a:ea typeface="Calibri" pitchFamily="34" charset="-122"/>
+                <a:cs typeface="Calibri" pitchFamily="34" charset="-120"/>
+              </a:rPr>
+              <a:t>Formats courts qui approfondissent un message, une actualité, un détail — fidéliser sans lasser.</a:t>
+            </a:r>
+            <a:endParaRPr lang="en-US" sz="1100" dirty="0"/>
+          </a:p>
+        </p:txBody>
+      </p:sp>
+      <p:sp>
+        <p:nvSpPr>
+          <p:cNvPr id="12" name="Text 10"/>
           <p:cNvSpPr/>
           <p:nvPr/>
         </p:nvSpPr>
@@ -5821,7 +5300,7 @@
                 <a:ea typeface="Georgia" pitchFamily="34" charset="-122"/>
                 <a:cs typeface="Georgia" pitchFamily="34" charset="-120"/>
               </a:rPr>
-              <a:t>Synthétiseur typographique</a:t>
+              <a:t>Internationalisation</a:t>
             </a:r>
             <a:endParaRPr lang="en-US" sz="3400" dirty="0"/>
           </a:p>
@@ -5860,7 +5339,7 @@
                 <a:ea typeface="Calibri" pitchFamily="34" charset="-122"/>
                 <a:cs typeface="Calibri" pitchFamily="34" charset="-120"/>
               </a:rPr>
-              <a:t>ASS/SSA · Safe-zones · Signature CESAR+</a:t>
+              <a:t>Clonage vocal EU · Pages satellites</a:t>
             </a:r>
             <a:endParaRPr lang="en-US" sz="1300" dirty="0"/>
           </a:p>
@@ -5949,7 +5428,7 @@
                 <a:ea typeface="Georgia" pitchFamily="34" charset="-122"/>
                 <a:cs typeface="Georgia" pitchFamily="34" charset="-120"/>
               </a:rPr>
-              <a:t>Purification glyphes</a:t>
+              <a:t>Clonage vocal européen</a:t>
             </a:r>
             <a:endParaRPr lang="en-US" sz="1400" dirty="0"/>
           </a:p>
@@ -5988,7 +5467,7 @@
                 <a:ea typeface="Calibri" pitchFamily="34" charset="-122"/>
                 <a:cs typeface="Calibri" pitchFamily="34" charset="-120"/>
               </a:rPr>
-              <a:t>Suppression des smart-quotes, calage FontSize 54, MarginV 240.</a:t>
+              <a:t>Traduction + clonage vocal dans toutes les langues parlées en Europe — même voix, même intention.</a:t>
             </a:r>
             <a:endParaRPr lang="en-US" sz="1100" dirty="0"/>
           </a:p>
@@ -6002,13 +5481,75 @@
         </p:nvSpPr>
         <p:spPr>
           <a:xfrm>
-            <a:off x="5029200" y="1691640"/>
-            <a:ext cx="1417320" cy="2834640"/>
-          </a:xfrm>
-          <a:prstGeom prst="rect">
-            <a:avLst>
-              <a:gd name="adj" fmla="val 7742"/>
-            </a:avLst>
+            <a:off x="4754880" y="1828800"/>
+            <a:ext cx="3931920" cy="2286000"/>
+          </a:xfrm>
+          <a:prstGeom prst="rect">
+            <a:avLst/>
+          </a:prstGeom>
+          <a:solidFill>
+            <a:srgbClr val="FFFFFF"/>
+          </a:solidFill>
+          <a:ln w="12700">
+            <a:solidFill>
+              <a:srgbClr val="D8D8D4"/>
+            </a:solidFill>
+            <a:prstDash val="solid"/>
+          </a:ln>
+        </p:spPr>
+      </p:sp>
+      <p:sp>
+        <p:nvSpPr>
+          <p:cNvPr id="9" name="Text 7"/>
+          <p:cNvSpPr/>
+          <p:nvPr/>
+        </p:nvSpPr>
+        <p:spPr>
+          <a:xfrm>
+            <a:off x="4937760" y="2011680"/>
+            <a:ext cx="1645920" cy="274320"/>
+          </a:xfrm>
+          <a:prstGeom prst="rect">
+            <a:avLst/>
+          </a:prstGeom>
+          <a:noFill/>
+          <a:ln/>
+        </p:spPr>
+        <p:txBody>
+          <a:bodyPr wrap="square" lIns="0" tIns="0" rIns="0" bIns="0" rtlCol="0" anchor="ctr"/>
+          <a:lstStyle/>
+          <a:p>
+            <a:pPr indent="0" marL="0">
+              <a:buNone/>
+            </a:pPr>
+            <a:r>
+              <a:rPr lang="en-US" sz="1100" b="1" dirty="0">
+                <a:solidFill>
+                  <a:srgbClr val="1A1A19"/>
+                </a:solidFill>
+                <a:latin typeface="Georgia" pitchFamily="34" charset="0"/>
+                <a:ea typeface="Georgia" pitchFamily="34" charset="-122"/>
+                <a:cs typeface="Georgia" pitchFamily="34" charset="-120"/>
+              </a:rPr>
+              <a:t>Compte officiel</a:t>
+            </a:r>
+            <a:endParaRPr lang="en-US" sz="1100" dirty="0"/>
+          </a:p>
+        </p:txBody>
+      </p:sp>
+      <p:sp>
+        <p:nvSpPr>
+          <p:cNvPr id="10" name="Shape 8"/>
+          <p:cNvSpPr/>
+          <p:nvPr/>
+        </p:nvSpPr>
+        <p:spPr>
+          <a:xfrm>
+            <a:off x="4937760" y="2331720"/>
+            <a:ext cx="1645920" cy="640080"/>
+          </a:xfrm>
+          <a:prstGeom prst="rect">
+            <a:avLst/>
           </a:prstGeom>
           <a:solidFill>
             <a:srgbClr val="1A1A19"/>
@@ -6023,64 +5564,14 @@
       </p:sp>
       <p:sp>
         <p:nvSpPr>
-          <p:cNvPr id="9" name="Shape 7"/>
-          <p:cNvSpPr/>
-          <p:nvPr/>
-        </p:nvSpPr>
-        <p:spPr>
-          <a:xfrm>
-            <a:off x="5120640" y="1856232"/>
-            <a:ext cx="1234440" cy="2331720"/>
-          </a:xfrm>
-          <a:prstGeom prst="rect">
-            <a:avLst/>
-          </a:prstGeom>
-          <a:solidFill>
-            <a:srgbClr val="2A2A28"/>
-          </a:solidFill>
-          <a:ln w="12700">
-            <a:solidFill>
-              <a:srgbClr val="2A2A28"/>
-            </a:solidFill>
-            <a:prstDash val="solid"/>
-          </a:ln>
-        </p:spPr>
-      </p:sp>
-      <p:sp>
-        <p:nvSpPr>
-          <p:cNvPr id="10" name="Shape 8"/>
-          <p:cNvSpPr/>
-          <p:nvPr/>
-        </p:nvSpPr>
-        <p:spPr>
-          <a:xfrm>
-            <a:off x="5193792" y="1947672"/>
-            <a:ext cx="566928" cy="201168"/>
-          </a:xfrm>
-          <a:prstGeom prst="rect">
-            <a:avLst/>
-          </a:prstGeom>
-          <a:solidFill>
-            <a:srgbClr val="FFFFFF"/>
-          </a:solidFill>
-          <a:ln w="12700">
-            <a:solidFill>
-              <a:srgbClr val="FFFFFF"/>
-            </a:solidFill>
-            <a:prstDash val="solid"/>
-          </a:ln>
-        </p:spPr>
-      </p:sp>
-      <p:sp>
-        <p:nvSpPr>
           <p:cNvPr id="11" name="Text 9"/>
           <p:cNvSpPr/>
           <p:nvPr/>
         </p:nvSpPr>
         <p:spPr>
           <a:xfrm>
-            <a:off x="5212080" y="1956816"/>
-            <a:ext cx="530352" cy="182880"/>
+            <a:off x="4937760" y="2377440"/>
+            <a:ext cx="1645920" cy="548640"/>
           </a:xfrm>
           <a:prstGeom prst="rect">
             <a:avLst/>
@@ -6096,14 +5587,28 @@
               <a:buNone/>
             </a:pPr>
             <a:r>
-              <a:rPr lang="en-US" sz="700" b="1" dirty="0">
-                <a:solidFill>
-                  <a:srgbClr val="1A1A19"/>
-                </a:solidFill>
-              </a:rPr>
-              <a:t>CESAR+</a:t>
-            </a:r>
-            <a:endParaRPr lang="en-US" sz="700" dirty="0"/>
+              <a:rPr lang="en-US" sz="1000" dirty="0">
+                <a:solidFill>
+                  <a:srgbClr val="FFFFFF"/>
+                </a:solidFill>
+              </a:rPr>
+              <a:t>Stats</a:t>
+            </a:r>
+            <a:endParaRPr lang="en-US" sz="1000" dirty="0"/>
+          </a:p>
+          <a:p>
+            <a:pPr algn="ctr" indent="0" marL="0">
+              <a:buNone/>
+            </a:pPr>
+            <a:r>
+              <a:rPr lang="en-US" sz="1000" dirty="0">
+                <a:solidFill>
+                  <a:srgbClr val="FFFFFF"/>
+                </a:solidFill>
+              </a:rPr>
+              <a:t>protégées</a:t>
+            </a:r>
+            <a:endParaRPr lang="en-US" sz="1000" dirty="0"/>
           </a:p>
         </p:txBody>
       </p:sp>
@@ -6115,8 +5620,8 @@
         </p:nvSpPr>
         <p:spPr>
           <a:xfrm>
-            <a:off x="6675120" y="1920240"/>
-            <a:ext cx="2103120" cy="1828800"/>
+            <a:off x="6766560" y="2011680"/>
+            <a:ext cx="1737360" cy="274320"/>
           </a:xfrm>
           <a:prstGeom prst="rect">
             <a:avLst/>
@@ -6128,64 +5633,100 @@
           <a:bodyPr wrap="square" lIns="0" tIns="0" rIns="0" bIns="0" rtlCol="0" anchor="ctr"/>
           <a:lstStyle/>
           <a:p>
-            <a:pPr marL="342900" indent="-342900">
-              <a:buSzPct val="100000"/>
-              <a:buChar char="•"/>
-            </a:pPr>
-            <a:r>
-              <a:rPr lang="en-US" sz="1100" dirty="0">
-                <a:solidFill>
-                  <a:srgbClr val="1A1A19"/>
+            <a:pPr indent="0" marL="0">
+              <a:buNone/>
+            </a:pPr>
+            <a:r>
+              <a:rPr lang="en-US" sz="1100" b="1" dirty="0">
+                <a:solidFill>
+                  <a:srgbClr val="B85042"/>
+                </a:solidFill>
+                <a:latin typeface="Georgia" pitchFamily="34" charset="0"/>
+                <a:ea typeface="Georgia" pitchFamily="34" charset="-122"/>
+                <a:cs typeface="Georgia" pitchFamily="34" charset="-120"/>
+              </a:rPr>
+              <a:t>Pages fan / satellites</a:t>
+            </a:r>
+            <a:endParaRPr lang="en-US" sz="1100" dirty="0"/>
+          </a:p>
+        </p:txBody>
+      </p:sp>
+      <p:sp>
+        <p:nvSpPr>
+          <p:cNvPr id="13" name="Text 11"/>
+          <p:cNvSpPr/>
+          <p:nvPr/>
+        </p:nvSpPr>
+        <p:spPr>
+          <a:xfrm>
+            <a:off x="6766560" y="2331720"/>
+            <a:ext cx="1737360" cy="1554480"/>
+          </a:xfrm>
+          <a:prstGeom prst="rect">
+            <a:avLst/>
+          </a:prstGeom>
+          <a:noFill/>
+          <a:ln/>
+        </p:spPr>
+        <p:txBody>
+          <a:bodyPr wrap="square" lIns="0" tIns="0" rIns="0" bIns="0" rtlCol="0" anchor="t"/>
+          <a:lstStyle/>
+          <a:p>
+            <a:pPr indent="0" marL="0">
+              <a:buNone/>
+            </a:pPr>
+            <a:r>
+              <a:rPr lang="en-US" sz="1000" dirty="0">
+                <a:solidFill>
+                  <a:srgbClr val="6B6B68"/>
                 </a:solidFill>
                 <a:latin typeface="Calibri" pitchFamily="34" charset="0"/>
                 <a:ea typeface="Calibri" pitchFamily="34" charset="-122"/>
                 <a:cs typeface="Calibri" pitchFamily="34" charset="-120"/>
               </a:rPr>
-              <a:t>Zones de sécurité mobiles</a:t>
-            </a:r>
-            <a:endParaRPr lang="en-US" sz="1100" dirty="0"/>
-          </a:p>
-          <a:p>
-            <a:pPr marL="342900" indent="-342900">
-              <a:buSzPct val="100000"/>
-              <a:buChar char="•"/>
-            </a:pPr>
-            <a:r>
-              <a:rPr lang="en-US" sz="1100" dirty="0">
-                <a:solidFill>
-                  <a:srgbClr val="1A1A19"/>
+              <a:t>FR · DE · ES · IT · PT · LV</a:t>
+            </a:r>
+            <a:endParaRPr lang="en-US" sz="1000" dirty="0"/>
+          </a:p>
+          <a:p>
+            <a:pPr indent="0" marL="0">
+              <a:buNone/>
+            </a:pPr>
+            <a:r>
+              <a:rPr lang="en-US" sz="1000" dirty="0">
+                <a:solidFill>
+                  <a:srgbClr val="6B6B68"/>
                 </a:solidFill>
                 <a:latin typeface="Calibri" pitchFamily="34" charset="0"/>
                 <a:ea typeface="Calibri" pitchFamily="34" charset="-122"/>
                 <a:cs typeface="Calibri" pitchFamily="34" charset="-120"/>
               </a:rPr>
-              <a:t>Watermark broadcast CESAR+</a:t>
-            </a:r>
-            <a:endParaRPr lang="en-US" sz="1100" dirty="0"/>
-          </a:p>
-          <a:p>
-            <a:pPr marL="342900" indent="-342900">
-              <a:buSzPct val="100000"/>
-              <a:buChar char="•"/>
-            </a:pPr>
-            <a:r>
-              <a:rPr lang="en-US" sz="1100" dirty="0">
-                <a:solidFill>
-                  <a:srgbClr val="1A1A19"/>
+              <a:t>Appui créatif journalier</a:t>
+            </a:r>
+            <a:endParaRPr lang="en-US" sz="1000" dirty="0"/>
+          </a:p>
+          <a:p>
+            <a:pPr indent="0" marL="0">
+              <a:buNone/>
+            </a:pPr>
+            <a:r>
+              <a:rPr lang="en-US" sz="1000" dirty="0">
+                <a:solidFill>
+                  <a:srgbClr val="6B6B68"/>
                 </a:solidFill>
                 <a:latin typeface="Calibri" pitchFamily="34" charset="0"/>
                 <a:ea typeface="Calibri" pitchFamily="34" charset="-122"/>
                 <a:cs typeface="Calibri" pitchFamily="34" charset="-120"/>
               </a:rPr>
-              <a:t>Zéro collision UI native</a:t>
-            </a:r>
-            <a:endParaRPr lang="en-US" sz="1100" dirty="0"/>
-          </a:p>
-        </p:txBody>
-      </p:sp>
-      <p:sp>
-        <p:nvSpPr>
-          <p:cNvPr id="13" name="Text 11"/>
+              <a:t>Sans cannibaliser l'engagement</a:t>
+            </a:r>
+            <a:endParaRPr lang="en-US" sz="1000" dirty="0"/>
+          </a:p>
+        </p:txBody>
+      </p:sp>
+      <p:sp>
+        <p:nvSpPr>
+          <p:cNvPr id="14" name="Text 12"/>
           <p:cNvSpPr/>
           <p:nvPr/>
         </p:nvSpPr>
@@ -6284,7 +5825,7 @@
                 <a:ea typeface="Georgia" pitchFamily="34" charset="-122"/>
                 <a:cs typeface="Georgia" pitchFamily="34" charset="-120"/>
               </a:rPr>
-              <a:t>Performance matérielle</a:t>
+              <a:t>Excellence motion</a:t>
             </a:r>
             <a:endParaRPr lang="en-US" sz="3400" dirty="0"/>
           </a:p>
@@ -6323,7 +5864,7 @@
                 <a:ea typeface="Calibri" pitchFamily="34" charset="-122"/>
                 <a:cs typeface="Calibri" pitchFamily="34" charset="-120"/>
               </a:rPr>
-              <a:t>Local-first · Zéro-coût · M3 Max</a:t>
+              <a:t>Contrôle typographique total</a:t>
             </a:r>
             <a:endParaRPr lang="en-US" sz="1300" dirty="0"/>
           </a:p>
@@ -6331,14 +5872,64 @@
       </p:sp>
       <p:sp>
         <p:nvSpPr>
-          <p:cNvPr id="4" name="Text 2"/>
-          <p:cNvSpPr/>
-          <p:nvPr/>
-        </p:nvSpPr>
-        <p:spPr>
-          <a:xfrm>
-            <a:off x="640080" y="2011680"/>
-            <a:ext cx="4572000" cy="731520"/>
+          <p:cNvPr id="4" name="Shape 2"/>
+          <p:cNvSpPr/>
+          <p:nvPr/>
+        </p:nvSpPr>
+        <p:spPr>
+          <a:xfrm>
+            <a:off x="640080" y="1828800"/>
+            <a:ext cx="3657600" cy="2286000"/>
+          </a:xfrm>
+          <a:prstGeom prst="rect">
+            <a:avLst/>
+          </a:prstGeom>
+          <a:solidFill>
+            <a:srgbClr val="FFFFFF"/>
+          </a:solidFill>
+          <a:ln w="12700">
+            <a:solidFill>
+              <a:srgbClr val="D8D8D4"/>
+            </a:solidFill>
+            <a:prstDash val="solid"/>
+          </a:ln>
+        </p:spPr>
+      </p:sp>
+      <p:sp>
+        <p:nvSpPr>
+          <p:cNvPr id="5" name="Shape 3"/>
+          <p:cNvSpPr/>
+          <p:nvPr/>
+        </p:nvSpPr>
+        <p:spPr>
+          <a:xfrm>
+            <a:off x="640080" y="1828800"/>
+            <a:ext cx="64008" cy="2286000"/>
+          </a:xfrm>
+          <a:prstGeom prst="rect">
+            <a:avLst/>
+          </a:prstGeom>
+          <a:solidFill>
+            <a:srgbClr val="B85042"/>
+          </a:solidFill>
+          <a:ln w="12700">
+            <a:solidFill>
+              <a:srgbClr val="B85042"/>
+            </a:solidFill>
+            <a:prstDash val="solid"/>
+          </a:ln>
+        </p:spPr>
+      </p:sp>
+      <p:sp>
+        <p:nvSpPr>
+          <p:cNvPr id="6" name="Text 4"/>
+          <p:cNvSpPr/>
+          <p:nvPr/>
+        </p:nvSpPr>
+        <p:spPr>
+          <a:xfrm>
+            <a:off x="841248" y="1993392"/>
+            <a:ext cx="3337560" cy="320040"/>
           </a:xfrm>
           <a:prstGeom prst="rect">
             <a:avLst/>
@@ -6354,106 +5945,74 @@
               <a:buNone/>
             </a:pPr>
             <a:r>
-              <a:rPr lang="en-US" sz="2800" b="1" dirty="0">
-                <a:solidFill>
-                  <a:srgbClr val="B85042"/>
-                </a:solidFill>
-                <a:latin typeface="Consolas" pitchFamily="34" charset="0"/>
-                <a:ea typeface="Consolas" pitchFamily="34" charset="-122"/>
-                <a:cs typeface="Consolas" pitchFamily="34" charset="-120"/>
-              </a:rPr>
-              <a:t>hevc_videotoolbox</a:t>
-            </a:r>
-            <a:endParaRPr lang="en-US" sz="2800" dirty="0"/>
-          </a:p>
-        </p:txBody>
-      </p:sp>
-      <p:sp>
-        <p:nvSpPr>
-          <p:cNvPr id="5" name="Text 3"/>
-          <p:cNvSpPr/>
-          <p:nvPr/>
-        </p:nvSpPr>
-        <p:spPr>
-          <a:xfrm>
-            <a:off x="640080" y="2926080"/>
-            <a:ext cx="5029200" cy="1371600"/>
-          </a:xfrm>
-          <a:prstGeom prst="rect">
-            <a:avLst/>
-          </a:prstGeom>
-          <a:noFill/>
-          <a:ln/>
-        </p:spPr>
-        <p:txBody>
-          <a:bodyPr wrap="square" lIns="0" tIns="0" rIns="0" bIns="0" rtlCol="0" anchor="ctr"/>
-          <a:lstStyle/>
-          <a:p>
-            <a:pPr indent="0" marL="0">
-              <a:buNone/>
-            </a:pPr>
-            <a:r>
-              <a:rPr lang="en-US" sz="1300" dirty="0">
+              <a:rPr lang="en-US" sz="1400" b="1" dirty="0">
                 <a:solidFill>
                   <a:srgbClr val="1A1A19"/>
+                </a:solidFill>
+                <a:latin typeface="Georgia" pitchFamily="34" charset="0"/>
+                <a:ea typeface="Georgia" pitchFamily="34" charset="-122"/>
+                <a:cs typeface="Georgia" pitchFamily="34" charset="-120"/>
+              </a:rPr>
+              <a:t>Synthèse motion design</a:t>
+            </a:r>
+            <a:endParaRPr lang="en-US" sz="1400" dirty="0"/>
+          </a:p>
+        </p:txBody>
+      </p:sp>
+      <p:sp>
+        <p:nvSpPr>
+          <p:cNvPr id="7" name="Text 5"/>
+          <p:cNvSpPr/>
+          <p:nvPr/>
+        </p:nvSpPr>
+        <p:spPr>
+          <a:xfrm>
+            <a:off x="841248" y="2331720"/>
+            <a:ext cx="3337560" cy="1645920"/>
+          </a:xfrm>
+          <a:prstGeom prst="rect">
+            <a:avLst/>
+          </a:prstGeom>
+          <a:noFill/>
+          <a:ln/>
+        </p:spPr>
+        <p:txBody>
+          <a:bodyPr wrap="square" lIns="0" tIns="0" rIns="0" bIns="0" rtlCol="0" anchor="t"/>
+          <a:lstStyle/>
+          <a:p>
+            <a:pPr indent="0" marL="0">
+              <a:buNone/>
+            </a:pPr>
+            <a:r>
+              <a:rPr lang="en-US" sz="1100" dirty="0">
+                <a:solidFill>
+                  <a:srgbClr val="6B6B68"/>
                 </a:solidFill>
                 <a:latin typeface="Calibri" pitchFamily="34" charset="0"/>
                 <a:ea typeface="Calibri" pitchFamily="34" charset="-122"/>
                 <a:cs typeface="Calibri" pitchFamily="34" charset="-120"/>
               </a:rPr>
-              <a:t>Encodage HEVC matériel Apple Silicon</a:t>
-            </a:r>
-            <a:endParaRPr lang="en-US" sz="1300" dirty="0"/>
-          </a:p>
-          <a:p>
-            <a:pPr indent="0" marL="0">
-              <a:buNone/>
-            </a:pPr>
-            <a:r>
-              <a:rPr lang="en-US" sz="1300" dirty="0">
-                <a:solidFill>
-                  <a:srgbClr val="1A1A19"/>
-                </a:solidFill>
-                <a:latin typeface="Calibri" pitchFamily="34" charset="0"/>
-                <a:ea typeface="Calibri" pitchFamily="34" charset="-122"/>
-                <a:cs typeface="Calibri" pitchFamily="34" charset="-120"/>
-              </a:rPr>
-              <a:t>Rendu local zéro-coût avant montée Cloud Run</a:t>
-            </a:r>
-            <a:endParaRPr lang="en-US" sz="1300" dirty="0"/>
-          </a:p>
-          <a:p>
-            <a:pPr indent="0" marL="0">
-              <a:buNone/>
-            </a:pPr>
-            <a:r>
-              <a:rPr lang="en-US" sz="1300" dirty="0">
-                <a:solidFill>
-                  <a:srgbClr val="1A1A19"/>
-                </a:solidFill>
-                <a:latin typeface="Calibri" pitchFamily="34" charset="0"/>
-                <a:ea typeface="Calibri" pitchFamily="34" charset="-122"/>
-                <a:cs typeface="Calibri" pitchFamily="34" charset="-120"/>
-              </a:rPr>
-              <a:t>Architecture hybride local-cloud souveraine</a:t>
-            </a:r>
-            <a:endParaRPr lang="en-US" sz="1300" dirty="0"/>
-          </a:p>
-        </p:txBody>
-      </p:sp>
-      <p:sp>
-        <p:nvSpPr>
-          <p:cNvPr id="6" name="Shape 4"/>
-          <p:cNvSpPr/>
-          <p:nvPr/>
-        </p:nvSpPr>
-        <p:spPr>
-          <a:xfrm>
-            <a:off x="5943600" y="1828800"/>
-            <a:ext cx="2743200" cy="2560320"/>
-          </a:xfrm>
-          <a:prstGeom prst="rect">
-            <a:avLst/>
+              <a:t>Rythme cinétique, compositions suisses, transitions beat-sync, grain organique — imposés à chaque sortie.</a:t>
+            </a:r>
+            <a:endParaRPr lang="en-US" sz="1100" dirty="0"/>
+          </a:p>
+        </p:txBody>
+      </p:sp>
+      <p:sp>
+        <p:nvSpPr>
+          <p:cNvPr id="8" name="Shape 6"/>
+          <p:cNvSpPr/>
+          <p:nvPr/>
+        </p:nvSpPr>
+        <p:spPr>
+          <a:xfrm>
+            <a:off x="5029200" y="1691640"/>
+            <a:ext cx="1417320" cy="2834640"/>
+          </a:xfrm>
+          <a:prstGeom prst="rect">
+            <a:avLst>
+              <a:gd name="adj" fmla="val 7742"/>
+            </a:avLst>
           </a:prstGeom>
           <a:solidFill>
             <a:srgbClr val="1A1A19"/>
@@ -6468,14 +6027,64 @@
       </p:sp>
       <p:sp>
         <p:nvSpPr>
-          <p:cNvPr id="7" name="Text 5"/>
-          <p:cNvSpPr/>
-          <p:nvPr/>
-        </p:nvSpPr>
-        <p:spPr>
-          <a:xfrm>
-            <a:off x="5943600" y="2286000"/>
-            <a:ext cx="2743200" cy="1645920"/>
+          <p:cNvPr id="9" name="Shape 7"/>
+          <p:cNvSpPr/>
+          <p:nvPr/>
+        </p:nvSpPr>
+        <p:spPr>
+          <a:xfrm>
+            <a:off x="5120640" y="1856232"/>
+            <a:ext cx="1234440" cy="2331720"/>
+          </a:xfrm>
+          <a:prstGeom prst="rect">
+            <a:avLst/>
+          </a:prstGeom>
+          <a:solidFill>
+            <a:srgbClr val="2A2A28"/>
+          </a:solidFill>
+          <a:ln w="12700">
+            <a:solidFill>
+              <a:srgbClr val="2A2A28"/>
+            </a:solidFill>
+            <a:prstDash val="solid"/>
+          </a:ln>
+        </p:spPr>
+      </p:sp>
+      <p:sp>
+        <p:nvSpPr>
+          <p:cNvPr id="10" name="Shape 8"/>
+          <p:cNvSpPr/>
+          <p:nvPr/>
+        </p:nvSpPr>
+        <p:spPr>
+          <a:xfrm>
+            <a:off x="5193792" y="1947672"/>
+            <a:ext cx="566928" cy="201168"/>
+          </a:xfrm>
+          <a:prstGeom prst="rect">
+            <a:avLst/>
+          </a:prstGeom>
+          <a:solidFill>
+            <a:srgbClr val="FFFFFF"/>
+          </a:solidFill>
+          <a:ln w="12700">
+            <a:solidFill>
+              <a:srgbClr val="FFFFFF"/>
+            </a:solidFill>
+            <a:prstDash val="solid"/>
+          </a:ln>
+        </p:spPr>
+      </p:sp>
+      <p:sp>
+        <p:nvSpPr>
+          <p:cNvPr id="11" name="Text 9"/>
+          <p:cNvSpPr/>
+          <p:nvPr/>
+        </p:nvSpPr>
+        <p:spPr>
+          <a:xfrm>
+            <a:off x="5212080" y="1956816"/>
+            <a:ext cx="530352" cy="182880"/>
           </a:xfrm>
           <a:prstGeom prst="rect">
             <a:avLst/>
@@ -6491,48 +6100,96 @@
               <a:buNone/>
             </a:pPr>
             <a:r>
-              <a:rPr lang="en-US" sz="1800" b="1" dirty="0">
-                <a:solidFill>
-                  <a:srgbClr val="FFFFFF"/>
-                </a:solidFill>
-              </a:rPr>
-              <a:t>M3 Max</a:t>
-            </a:r>
-            <a:endParaRPr lang="en-US" sz="1800" dirty="0"/>
-          </a:p>
-          <a:p>
-            <a:pPr algn="ctr" indent="0" marL="0">
-              <a:buNone/>
-            </a:pPr>
-            <a:r>
-              <a:rPr lang="en-US" sz="1800" b="1" dirty="0">
-                <a:solidFill>
-                  <a:srgbClr val="FFFFFF"/>
-                </a:solidFill>
-              </a:rPr>
-              <a:t>GPU</a:t>
-            </a:r>
-            <a:endParaRPr lang="en-US" sz="1800" dirty="0"/>
-          </a:p>
-          <a:p>
-            <a:pPr algn="ctr" indent="0" marL="0">
-              <a:buNone/>
-            </a:pPr>
-            <a:r>
-              <a:rPr lang="en-US" sz="1800" b="1" dirty="0">
-                <a:solidFill>
-                  <a:srgbClr val="FFFFFF"/>
-                </a:solidFill>
-              </a:rPr>
-              <a:t>HEVC</a:t>
-            </a:r>
-            <a:endParaRPr lang="en-US" sz="1800" dirty="0"/>
-          </a:p>
-        </p:txBody>
-      </p:sp>
-      <p:sp>
-        <p:nvSpPr>
-          <p:cNvPr id="8" name="Text 6"/>
+              <a:rPr lang="en-US" sz="700" b="1" dirty="0">
+                <a:solidFill>
+                  <a:srgbClr val="1A1A19"/>
+                </a:solidFill>
+              </a:rPr>
+              <a:t>CESAR+</a:t>
+            </a:r>
+            <a:endParaRPr lang="en-US" sz="700" dirty="0"/>
+          </a:p>
+        </p:txBody>
+      </p:sp>
+      <p:sp>
+        <p:nvSpPr>
+          <p:cNvPr id="12" name="Text 10"/>
+          <p:cNvSpPr/>
+          <p:nvPr/>
+        </p:nvSpPr>
+        <p:spPr>
+          <a:xfrm>
+            <a:off x="6675120" y="1920240"/>
+            <a:ext cx="2103120" cy="1828800"/>
+          </a:xfrm>
+          <a:prstGeom prst="rect">
+            <a:avLst/>
+          </a:prstGeom>
+          <a:noFill/>
+          <a:ln/>
+        </p:spPr>
+        <p:txBody>
+          <a:bodyPr wrap="square" lIns="0" tIns="0" rIns="0" bIns="0" rtlCol="0" anchor="ctr"/>
+          <a:lstStyle/>
+          <a:p>
+            <a:pPr marL="342900" indent="-342900">
+              <a:buSzPct val="100000"/>
+              <a:buChar char="•"/>
+            </a:pPr>
+            <a:r>
+              <a:rPr lang="en-US" sz="1100" dirty="0">
+                <a:solidFill>
+                  <a:srgbClr val="1A1A19"/>
+                </a:solidFill>
+                <a:latin typeface="Calibri" pitchFamily="34" charset="0"/>
+                <a:ea typeface="Calibri" pitchFamily="34" charset="-122"/>
+                <a:cs typeface="Calibri" pitchFamily="34" charset="-120"/>
+              </a:rPr>
+              <a:t>Contrôle total des sous-titres</a:t>
+            </a:r>
+            <a:endParaRPr lang="en-US" sz="1100" dirty="0"/>
+          </a:p>
+          <a:p>
+            <a:pPr marL="342900" indent="-342900">
+              <a:buSzPct val="100000"/>
+              <a:buChar char="•"/>
+            </a:pPr>
+            <a:r>
+              <a:rPr lang="en-US" sz="1100" dirty="0">
+                <a:solidFill>
+                  <a:srgbClr val="1A1A19"/>
+                </a:solidFill>
+                <a:latin typeface="Calibri" pitchFamily="34" charset="0"/>
+                <a:ea typeface="Calibri" pitchFamily="34" charset="-122"/>
+                <a:cs typeface="Calibri" pitchFamily="34" charset="-120"/>
+              </a:rPr>
+              <a:t>Zones de sécurité mobiles</a:t>
+            </a:r>
+            <a:endParaRPr lang="en-US" sz="1100" dirty="0"/>
+          </a:p>
+          <a:p>
+            <a:pPr marL="342900" indent="-342900">
+              <a:buSzPct val="100000"/>
+              <a:buChar char="•"/>
+            </a:pPr>
+            <a:r>
+              <a:rPr lang="en-US" sz="1100" dirty="0">
+                <a:solidFill>
+                  <a:srgbClr val="1A1A19"/>
+                </a:solidFill>
+                <a:latin typeface="Calibri" pitchFamily="34" charset="0"/>
+                <a:ea typeface="Calibri" pitchFamily="34" charset="-122"/>
+                <a:cs typeface="Calibri" pitchFamily="34" charset="-120"/>
+              </a:rPr>
+              <a:t>Signature broadcast CESAR+</a:t>
+            </a:r>
+            <a:endParaRPr lang="en-US" sz="1100" dirty="0"/>
+          </a:p>
+        </p:txBody>
+      </p:sp>
+      <p:sp>
+        <p:nvSpPr>
+          <p:cNvPr id="13" name="Text 11"/>
           <p:cNvSpPr/>
           <p:nvPr/>
         </p:nvSpPr>
@@ -6631,7 +6288,7 @@
                 <a:ea typeface="Georgia" pitchFamily="34" charset="-122"/>
                 <a:cs typeface="Georgia" pitchFamily="34" charset="-120"/>
               </a:rPr>
-              <a:t>Scaling tokens</a:t>
+              <a:t>Déploiement cloud</a:t>
             </a:r>
             <a:endParaRPr lang="en-US" sz="3400" dirty="0"/>
           </a:p>
@@ -6670,7 +6327,7 @@
                 <a:ea typeface="Calibri" pitchFamily="34" charset="-122"/>
                 <a:cs typeface="Calibri" pitchFamily="34" charset="-120"/>
               </a:rPr>
-              <a:t>Justification crédits cloud entreprise</a:t>
+              <a:t>Pipeline validé · Scale enterprise</a:t>
             </a:r>
             <a:endParaRPr lang="en-US" sz="1300" dirty="0"/>
           </a:p>
@@ -6684,8 +6341,8 @@
         </p:nvSpPr>
         <p:spPr>
           <a:xfrm>
-            <a:off x="640080" y="1828800"/>
-            <a:ext cx="5029200" cy="1097280"/>
+            <a:off x="640080" y="2011680"/>
+            <a:ext cx="4572000" cy="731520"/>
           </a:xfrm>
           <a:prstGeom prst="rect">
             <a:avLst/>
@@ -6701,17 +6358,17 @@
               <a:buNone/>
             </a:pPr>
             <a:r>
-              <a:rPr lang="en-US" sz="7200" b="1" dirty="0">
+              <a:rPr lang="en-US" sz="2800" b="1" dirty="0">
                 <a:solidFill>
                   <a:srgbClr val="B85042"/>
                 </a:solidFill>
-                <a:latin typeface="Georgia" pitchFamily="34" charset="0"/>
-                <a:ea typeface="Georgia" pitchFamily="34" charset="-122"/>
-                <a:cs typeface="Georgia" pitchFamily="34" charset="-120"/>
-              </a:rPr>
-              <a:t>64,3</a:t>
-            </a:r>
-            <a:endParaRPr lang="en-US" sz="7200" dirty="0"/>
+                <a:latin typeface="Consolas" pitchFamily="34" charset="0"/>
+                <a:ea typeface="Consolas" pitchFamily="34" charset="-122"/>
+                <a:cs typeface="Consolas" pitchFamily="34" charset="-120"/>
+              </a:rPr>
+              <a:t>CLOUD READY</a:t>
+            </a:r>
+            <a:endParaRPr lang="en-US" sz="2800" dirty="0"/>
           </a:p>
         </p:txBody>
       </p:sp>
@@ -6723,8 +6380,8 @@
         </p:nvSpPr>
         <p:spPr>
           <a:xfrm>
-            <a:off x="640080" y="2834640"/>
-            <a:ext cx="5029200" cy="457200"/>
+            <a:off x="640080" y="2926080"/>
+            <a:ext cx="5029200" cy="1371600"/>
           </a:xfrm>
           <a:prstGeom prst="rect">
             <a:avLst/>
@@ -6740,7 +6397,7 @@
               <a:buNone/>
             </a:pPr>
             <a:r>
-              <a:rPr lang="en-US" sz="1800" dirty="0">
+              <a:rPr lang="en-US" sz="1300" dirty="0">
                 <a:solidFill>
                   <a:srgbClr val="1A1A19"/>
                 </a:solidFill>
@@ -6748,71 +6405,66 @@
                 <a:ea typeface="Calibri" pitchFamily="34" charset="-122"/>
                 <a:cs typeface="Calibri" pitchFamily="34" charset="-120"/>
               </a:rPr>
-              <a:t>Millions de tokens / mois</a:t>
-            </a:r>
-            <a:endParaRPr lang="en-US" sz="1800" dirty="0"/>
-          </a:p>
-        </p:txBody>
-      </p:sp>
-      <p:sp>
-        <p:nvSpPr>
-          <p:cNvPr id="6" name="Text 4"/>
-          <p:cNvSpPr/>
-          <p:nvPr/>
-        </p:nvSpPr>
-        <p:spPr>
-          <a:xfrm>
-            <a:off x="640080" y="3383280"/>
-            <a:ext cx="7772400" cy="365760"/>
-          </a:xfrm>
-          <a:prstGeom prst="rect">
-            <a:avLst/>
-          </a:prstGeom>
-          <a:noFill/>
-          <a:ln/>
-        </p:spPr>
-        <p:txBody>
-          <a:bodyPr wrap="square" lIns="0" tIns="0" rIns="0" bIns="0" rtlCol="0" anchor="ctr"/>
-          <a:lstStyle/>
-          <a:p>
-            <a:pPr indent="0" marL="0">
-              <a:buNone/>
-            </a:pPr>
-            <a:r>
-              <a:rPr lang="en-US" sz="1000" dirty="0">
-                <a:solidFill>
-                  <a:srgbClr val="6B6B68"/>
-                </a:solidFill>
-                <a:latin typeface="Consolas" pitchFamily="34" charset="0"/>
-                <a:ea typeface="Consolas" pitchFamily="34" charset="-122"/>
-                <a:cs typeface="Consolas" pitchFamily="34" charset="-120"/>
-              </a:rPr>
-              <a:t>50 cycles × 31 000 tokens × 30 jours  |  350 sorties localisées/jour</a:t>
-            </a:r>
-            <a:endParaRPr lang="en-US" sz="1000" dirty="0"/>
-          </a:p>
-        </p:txBody>
-      </p:sp>
-      <p:sp>
-        <p:nvSpPr>
-          <p:cNvPr id="7" name="Shape 5"/>
-          <p:cNvSpPr/>
-          <p:nvPr/>
-        </p:nvSpPr>
-        <p:spPr>
-          <a:xfrm>
-            <a:off x="6217920" y="1828800"/>
-            <a:ext cx="2468880" cy="2286000"/>
+              <a:t>Orchestration multi-agents · Rendu parallèle</a:t>
+            </a:r>
+            <a:endParaRPr lang="en-US" sz="1300" dirty="0"/>
+          </a:p>
+          <a:p>
+            <a:pPr indent="0" marL="0">
+              <a:buNone/>
+            </a:pPr>
+            <a:r>
+              <a:rPr lang="en-US" sz="1300" dirty="0">
+                <a:solidFill>
+                  <a:srgbClr val="1A1A19"/>
+                </a:solidFill>
+                <a:latin typeface="Calibri" pitchFamily="34" charset="0"/>
+                <a:ea typeface="Calibri" pitchFamily="34" charset="-122"/>
+                <a:cs typeface="Calibri" pitchFamily="34" charset="-120"/>
+              </a:rPr>
+              <a:t>Google Cloud Run · Azure AKS · AWS Fargate</a:t>
+            </a:r>
+            <a:endParaRPr lang="en-US" sz="1300" dirty="0"/>
+          </a:p>
+          <a:p>
+            <a:pPr indent="0" marL="0">
+              <a:buNone/>
+            </a:pPr>
+            <a:r>
+              <a:rPr lang="en-US" sz="1300" dirty="0">
+                <a:solidFill>
+                  <a:srgbClr val="1A1A19"/>
+                </a:solidFill>
+                <a:latin typeface="Calibri" pitchFamily="34" charset="0"/>
+                <a:ea typeface="Calibri" pitchFamily="34" charset="-122"/>
+                <a:cs typeface="Calibri" pitchFamily="34" charset="-120"/>
+              </a:rPr>
+              <a:t>Montée en charge horizontale sans compromis esthétique</a:t>
+            </a:r>
+            <a:endParaRPr lang="en-US" sz="1300" dirty="0"/>
+          </a:p>
+        </p:txBody>
+      </p:sp>
+      <p:sp>
+        <p:nvSpPr>
+          <p:cNvPr id="6" name="Shape 4"/>
+          <p:cNvSpPr/>
+          <p:nvPr/>
+        </p:nvSpPr>
+        <p:spPr>
+          <a:xfrm>
+            <a:off x="5943600" y="1828800"/>
+            <a:ext cx="2743200" cy="2560320"/>
           </a:xfrm>
           <a:prstGeom prst="rect">
             <a:avLst/>
           </a:prstGeom>
           <a:solidFill>
-            <a:srgbClr val="E7E8D1"/>
+            <a:srgbClr val="1A1A19"/>
           </a:solidFill>
           <a:ln w="12700">
             <a:solidFill>
-              <a:srgbClr val="D8D8D4"/>
+              <a:srgbClr val="1A1A19"/>
             </a:solidFill>
             <a:prstDash val="solid"/>
           </a:ln>
@@ -6820,71 +6472,71 @@
       </p:sp>
       <p:sp>
         <p:nvSpPr>
+          <p:cNvPr id="7" name="Text 5"/>
+          <p:cNvSpPr/>
+          <p:nvPr/>
+        </p:nvSpPr>
+        <p:spPr>
+          <a:xfrm>
+            <a:off x="5943600" y="2194560"/>
+            <a:ext cx="2743200" cy="1828800"/>
+          </a:xfrm>
+          <a:prstGeom prst="rect">
+            <a:avLst/>
+          </a:prstGeom>
+          <a:noFill/>
+          <a:ln/>
+        </p:spPr>
+        <p:txBody>
+          <a:bodyPr wrap="square" lIns="0" tIns="0" rIns="0" bIns="0" rtlCol="0" anchor="ctr"/>
+          <a:lstStyle/>
+          <a:p>
+            <a:pPr algn="ctr" indent="0" marL="0">
+              <a:buNone/>
+            </a:pPr>
+            <a:r>
+              <a:rPr lang="en-US" sz="1600" b="1" dirty="0">
+                <a:solidFill>
+                  <a:srgbClr val="FFFFFF"/>
+                </a:solidFill>
+              </a:rPr>
+              <a:t>Multi-Agent</a:t>
+            </a:r>
+            <a:endParaRPr lang="en-US" sz="1600" dirty="0"/>
+          </a:p>
+          <a:p>
+            <a:pPr algn="ctr" indent="0" marL="0">
+              <a:buNone/>
+            </a:pPr>
+            <a:r>
+              <a:rPr lang="en-US" sz="1600" b="1" dirty="0">
+                <a:solidFill>
+                  <a:srgbClr val="FFFFFF"/>
+                </a:solidFill>
+              </a:rPr>
+              <a:t>Orchestration</a:t>
+            </a:r>
+            <a:endParaRPr lang="en-US" sz="1600" dirty="0"/>
+          </a:p>
+          <a:p>
+            <a:pPr algn="ctr" indent="0" marL="0">
+              <a:buNone/>
+            </a:pPr>
+            <a:r>
+              <a:rPr lang="en-US" sz="1600" b="1" dirty="0">
+                <a:solidFill>
+                  <a:srgbClr val="FFFFFF"/>
+                </a:solidFill>
+              </a:rPr>
+              <a:t>Enterprise</a:t>
+            </a:r>
+            <a:endParaRPr lang="en-US" sz="1600" dirty="0"/>
+          </a:p>
+        </p:txBody>
+      </p:sp>
+      <p:sp>
+        <p:nvSpPr>
           <p:cNvPr id="8" name="Text 6"/>
-          <p:cNvSpPr/>
-          <p:nvPr/>
-        </p:nvSpPr>
-        <p:spPr>
-          <a:xfrm>
-            <a:off x="6309360" y="2103120"/>
-            <a:ext cx="2286000" cy="1828800"/>
-          </a:xfrm>
-          <a:prstGeom prst="rect">
-            <a:avLst/>
-          </a:prstGeom>
-          <a:noFill/>
-          <a:ln/>
-        </p:spPr>
-        <p:txBody>
-          <a:bodyPr wrap="square" lIns="0" tIns="0" rIns="0" bIns="0" rtlCol="0" anchor="ctr"/>
-          <a:lstStyle/>
-          <a:p>
-            <a:pPr algn="ctr" indent="0" marL="0">
-              <a:buNone/>
-            </a:pPr>
-            <a:r>
-              <a:rPr lang="en-US" sz="1200" b="1" dirty="0">
-                <a:solidFill>
-                  <a:srgbClr val="1A1A19"/>
-                </a:solidFill>
-              </a:rPr>
-              <a:t>Cible crédits</a:t>
-            </a:r>
-            <a:endParaRPr lang="en-US" sz="1200" dirty="0"/>
-          </a:p>
-          <a:p>
-            <a:pPr algn="ctr" indent="0" marL="0">
-              <a:buNone/>
-            </a:pPr>
-            <a:r>
-              <a:rPr lang="en-US" sz="1200" b="1" dirty="0">
-                <a:solidFill>
-                  <a:srgbClr val="1A1A19"/>
-                </a:solidFill>
-              </a:rPr>
-              <a:t>$25k – $100k</a:t>
-            </a:r>
-            <a:endParaRPr lang="en-US" sz="1200" dirty="0"/>
-          </a:p>
-          <a:p>
-            <a:pPr algn="ctr" indent="0" marL="0">
-              <a:buNone/>
-            </a:pPr>
-            <a:r>
-              <a:rPr lang="en-US" sz="1200" b="1" dirty="0">
-                <a:solidFill>
-                  <a:srgbClr val="1A1A19"/>
-                </a:solidFill>
-              </a:rPr>
-              <a:t>via HAL Station F</a:t>
-            </a:r>
-            <a:endParaRPr lang="en-US" sz="1200" dirty="0"/>
-          </a:p>
-        </p:txBody>
-      </p:sp>
-      <p:sp>
-        <p:nvSpPr>
-          <p:cNvPr id="9" name="Text 7"/>
           <p:cNvSpPr/>
           <p:nvPr/>
         </p:nvSpPr>

</xml_diff>